<commit_message>
Selected Method Pablo, Literature Review Pablo & Datasets slides
</commit_message>
<xml_diff>
--- a/docs/GIDIA_VA_Course_Project_Presentations.pptx
+++ b/docs/GIDIA_VA_Course_Project_Presentations.pptx
@@ -5,10 +5,10 @@
     <p:sldMasterId id="2147483648" r:id="rId1"/>
   </p:sldMasterIdLst>
   <p:notesMasterIdLst>
-    <p:notesMasterId r:id="rId15"/>
+    <p:notesMasterId r:id="rId18"/>
   </p:notesMasterIdLst>
   <p:handoutMasterIdLst>
-    <p:handoutMasterId r:id="rId16"/>
+    <p:handoutMasterId r:id="rId19"/>
   </p:handoutMasterIdLst>
   <p:sldIdLst>
     <p:sldId id="257" r:id="rId2"/>
@@ -17,13 +17,16 @@
     <p:sldId id="403" r:id="rId5"/>
     <p:sldId id="318" r:id="rId6"/>
     <p:sldId id="411" r:id="rId7"/>
-    <p:sldId id="405" r:id="rId8"/>
-    <p:sldId id="409" r:id="rId9"/>
-    <p:sldId id="412" r:id="rId10"/>
-    <p:sldId id="413" r:id="rId11"/>
-    <p:sldId id="383" r:id="rId12"/>
-    <p:sldId id="404" r:id="rId13"/>
-    <p:sldId id="287" r:id="rId14"/>
+    <p:sldId id="414" r:id="rId8"/>
+    <p:sldId id="405" r:id="rId9"/>
+    <p:sldId id="409" r:id="rId10"/>
+    <p:sldId id="412" r:id="rId11"/>
+    <p:sldId id="413" r:id="rId12"/>
+    <p:sldId id="415" r:id="rId13"/>
+    <p:sldId id="416" r:id="rId14"/>
+    <p:sldId id="383" r:id="rId15"/>
+    <p:sldId id="404" r:id="rId16"/>
+    <p:sldId id="287" r:id="rId17"/>
   </p:sldIdLst>
   <p:sldSz cx="9144000" cy="6858000" type="screen4x3"/>
   <p:notesSz cx="6858000" cy="9144000"/>
@@ -764,6 +767,236 @@
   <p:cSld>
     <p:spTree>
       <p:nvGrpSpPr>
+        <p:cNvPr id="1" name="">
+          <a:extLst>
+            <a:ext uri="{FF2B5EF4-FFF2-40B4-BE49-F238E27FC236}">
+              <a16:creationId xmlns:a16="http://schemas.microsoft.com/office/drawing/2014/main" id="{A4F9270A-DA4B-D6B3-1A4F-AC85BE5F2D7E}"/>
+            </a:ext>
+          </a:extLst>
+        </p:cNvPr>
+        <p:cNvGrpSpPr/>
+        <p:nvPr/>
+      </p:nvGrpSpPr>
+      <p:grpSpPr>
+        <a:xfrm>
+          <a:off x="0" y="0"/>
+          <a:ext cx="0" cy="0"/>
+          <a:chOff x="0" y="0"/>
+          <a:chExt cx="0" cy="0"/>
+        </a:xfrm>
+      </p:grpSpPr>
+      <p:sp>
+        <p:nvSpPr>
+          <p:cNvPr id="2" name="Marcador de imagen de diapositiva 1">
+            <a:extLst>
+              <a:ext uri="{FF2B5EF4-FFF2-40B4-BE49-F238E27FC236}">
+                <a16:creationId xmlns:a16="http://schemas.microsoft.com/office/drawing/2014/main" id="{F00F5546-FA97-3766-B1FC-A47DE9795541}"/>
+              </a:ext>
+            </a:extLst>
+          </p:cNvPr>
+          <p:cNvSpPr>
+            <a:spLocks noGrp="1" noRot="1" noChangeAspect="1"/>
+          </p:cNvSpPr>
+          <p:nvPr>
+            <p:ph type="sldImg"/>
+          </p:nvPr>
+        </p:nvSpPr>
+        <p:spPr/>
+        <p:txBody>
+          <a:bodyPr/>
+          <a:lstStyle/>
+          <a:p>
+            <a:endParaRPr lang="es-ES" dirty="0"/>
+          </a:p>
+        </p:txBody>
+      </p:sp>
+      <p:sp>
+        <p:nvSpPr>
+          <p:cNvPr id="3" name="Marcador de notas 2">
+            <a:extLst>
+              <a:ext uri="{FF2B5EF4-FFF2-40B4-BE49-F238E27FC236}">
+                <a16:creationId xmlns:a16="http://schemas.microsoft.com/office/drawing/2014/main" id="{7D4517E9-EA07-54A2-DBB7-3635C5A646F4}"/>
+              </a:ext>
+            </a:extLst>
+          </p:cNvPr>
+          <p:cNvSpPr>
+            <a:spLocks noGrp="1"/>
+          </p:cNvSpPr>
+          <p:nvPr>
+            <p:ph type="body" idx="1"/>
+          </p:nvPr>
+        </p:nvSpPr>
+        <p:spPr/>
+        <p:txBody>
+          <a:bodyPr/>
+          <a:lstStyle/>
+          <a:p>
+            <a:endParaRPr lang="es-ES" dirty="0"/>
+          </a:p>
+        </p:txBody>
+      </p:sp>
+      <p:sp>
+        <p:nvSpPr>
+          <p:cNvPr id="4" name="Marcador de número de diapositiva 3">
+            <a:extLst>
+              <a:ext uri="{FF2B5EF4-FFF2-40B4-BE49-F238E27FC236}">
+                <a16:creationId xmlns:a16="http://schemas.microsoft.com/office/drawing/2014/main" id="{1974EE48-B9C3-3420-C006-3474E81EDC5E}"/>
+              </a:ext>
+            </a:extLst>
+          </p:cNvPr>
+          <p:cNvSpPr>
+            <a:spLocks noGrp="1"/>
+          </p:cNvSpPr>
+          <p:nvPr>
+            <p:ph type="sldNum" sz="quarter" idx="10"/>
+          </p:nvPr>
+        </p:nvSpPr>
+        <p:spPr/>
+        <p:txBody>
+          <a:bodyPr/>
+          <a:lstStyle/>
+          <a:p>
+            <a:fld id="{05D135E5-457A-4183-A722-09BD01DC1252}" type="slidenum">
+              <a:rPr lang="es-ES" smtClean="0"/>
+              <a:t>12</a:t>
+            </a:fld>
+            <a:endParaRPr lang="es-ES" dirty="0"/>
+          </a:p>
+        </p:txBody>
+      </p:sp>
+    </p:spTree>
+    <p:extLst>
+      <p:ext uri="{BB962C8B-B14F-4D97-AF65-F5344CB8AC3E}">
+        <p14:creationId xmlns:p14="http://schemas.microsoft.com/office/powerpoint/2010/main" val="2621593514"/>
+      </p:ext>
+    </p:extLst>
+  </p:cSld>
+  <p:clrMapOvr>
+    <a:masterClrMapping/>
+  </p:clrMapOvr>
+</p:notes>
+</file>
+
+<file path=ppt/notesSlides/notesSlide11.xml><?xml version="1.0" encoding="utf-8"?>
+<p:notes xmlns:a="http://schemas.openxmlformats.org/drawingml/2006/main" xmlns:r="http://schemas.openxmlformats.org/officeDocument/2006/relationships" xmlns:p="http://schemas.openxmlformats.org/presentationml/2006/main">
+  <p:cSld>
+    <p:spTree>
+      <p:nvGrpSpPr>
+        <p:cNvPr id="1" name="">
+          <a:extLst>
+            <a:ext uri="{FF2B5EF4-FFF2-40B4-BE49-F238E27FC236}">
+              <a16:creationId xmlns:a16="http://schemas.microsoft.com/office/drawing/2014/main" id="{608E4D33-155B-BD0B-9082-931E380F7456}"/>
+            </a:ext>
+          </a:extLst>
+        </p:cNvPr>
+        <p:cNvGrpSpPr/>
+        <p:nvPr/>
+      </p:nvGrpSpPr>
+      <p:grpSpPr>
+        <a:xfrm>
+          <a:off x="0" y="0"/>
+          <a:ext cx="0" cy="0"/>
+          <a:chOff x="0" y="0"/>
+          <a:chExt cx="0" cy="0"/>
+        </a:xfrm>
+      </p:grpSpPr>
+      <p:sp>
+        <p:nvSpPr>
+          <p:cNvPr id="2" name="Marcador de imagen de diapositiva 1">
+            <a:extLst>
+              <a:ext uri="{FF2B5EF4-FFF2-40B4-BE49-F238E27FC236}">
+                <a16:creationId xmlns:a16="http://schemas.microsoft.com/office/drawing/2014/main" id="{82CE4934-B702-5646-10D4-1D649A658807}"/>
+              </a:ext>
+            </a:extLst>
+          </p:cNvPr>
+          <p:cNvSpPr>
+            <a:spLocks noGrp="1" noRot="1" noChangeAspect="1"/>
+          </p:cNvSpPr>
+          <p:nvPr>
+            <p:ph type="sldImg"/>
+          </p:nvPr>
+        </p:nvSpPr>
+        <p:spPr/>
+        <p:txBody>
+          <a:bodyPr/>
+          <a:lstStyle/>
+          <a:p>
+            <a:endParaRPr lang="es-ES" dirty="0"/>
+          </a:p>
+        </p:txBody>
+      </p:sp>
+      <p:sp>
+        <p:nvSpPr>
+          <p:cNvPr id="3" name="Marcador de notas 2">
+            <a:extLst>
+              <a:ext uri="{FF2B5EF4-FFF2-40B4-BE49-F238E27FC236}">
+                <a16:creationId xmlns:a16="http://schemas.microsoft.com/office/drawing/2014/main" id="{78B3B6D4-DA43-3FB4-35B2-4951DB4102C4}"/>
+              </a:ext>
+            </a:extLst>
+          </p:cNvPr>
+          <p:cNvSpPr>
+            <a:spLocks noGrp="1"/>
+          </p:cNvSpPr>
+          <p:nvPr>
+            <p:ph type="body" idx="1"/>
+          </p:nvPr>
+        </p:nvSpPr>
+        <p:spPr/>
+        <p:txBody>
+          <a:bodyPr/>
+          <a:lstStyle/>
+          <a:p>
+            <a:endParaRPr lang="es-ES" dirty="0"/>
+          </a:p>
+        </p:txBody>
+      </p:sp>
+      <p:sp>
+        <p:nvSpPr>
+          <p:cNvPr id="4" name="Marcador de número de diapositiva 3">
+            <a:extLst>
+              <a:ext uri="{FF2B5EF4-FFF2-40B4-BE49-F238E27FC236}">
+                <a16:creationId xmlns:a16="http://schemas.microsoft.com/office/drawing/2014/main" id="{7CFF2683-54CE-3710-F794-F81D49D4BD00}"/>
+              </a:ext>
+            </a:extLst>
+          </p:cNvPr>
+          <p:cNvSpPr>
+            <a:spLocks noGrp="1"/>
+          </p:cNvSpPr>
+          <p:nvPr>
+            <p:ph type="sldNum" sz="quarter" idx="10"/>
+          </p:nvPr>
+        </p:nvSpPr>
+        <p:spPr/>
+        <p:txBody>
+          <a:bodyPr/>
+          <a:lstStyle/>
+          <a:p>
+            <a:fld id="{05D135E5-457A-4183-A722-09BD01DC1252}" type="slidenum">
+              <a:rPr lang="es-ES" smtClean="0"/>
+              <a:t>13</a:t>
+            </a:fld>
+            <a:endParaRPr lang="es-ES" dirty="0"/>
+          </a:p>
+        </p:txBody>
+      </p:sp>
+    </p:spTree>
+    <p:extLst>
+      <p:ext uri="{BB962C8B-B14F-4D97-AF65-F5344CB8AC3E}">
+        <p14:creationId xmlns:p14="http://schemas.microsoft.com/office/powerpoint/2010/main" val="623444326"/>
+      </p:ext>
+    </p:extLst>
+  </p:cSld>
+  <p:clrMapOvr>
+    <a:masterClrMapping/>
+  </p:clrMapOvr>
+</p:notes>
+</file>
+
+<file path=ppt/notesSlides/notesSlide12.xml><?xml version="1.0" encoding="utf-8"?>
+<p:notes xmlns:a="http://schemas.openxmlformats.org/drawingml/2006/main" xmlns:r="http://schemas.openxmlformats.org/officeDocument/2006/relationships" xmlns:p="http://schemas.openxmlformats.org/presentationml/2006/main">
+  <p:cSld>
+    <p:spTree>
+      <p:nvGrpSpPr>
         <p:cNvPr id="1" name=""/>
         <p:cNvGrpSpPr/>
         <p:nvPr/>
@@ -831,7 +1064,98 @@
           <a:p>
             <a:fld id="{05D135E5-457A-4183-A722-09BD01DC1252}" type="slidenum">
               <a:rPr lang="es-ES" smtClean="0"/>
-              <a:t>12</a:t>
+              <a:t>14</a:t>
+            </a:fld>
+            <a:endParaRPr lang="es-ES" dirty="0"/>
+          </a:p>
+        </p:txBody>
+      </p:sp>
+    </p:spTree>
+    <p:extLst>
+      <p:ext uri="{BB962C8B-B14F-4D97-AF65-F5344CB8AC3E}">
+        <p14:creationId xmlns:p14="http://schemas.microsoft.com/office/powerpoint/2010/main" val="556698752"/>
+      </p:ext>
+    </p:extLst>
+  </p:cSld>
+  <p:clrMapOvr>
+    <a:masterClrMapping/>
+  </p:clrMapOvr>
+</p:notes>
+</file>
+
+<file path=ppt/notesSlides/notesSlide13.xml><?xml version="1.0" encoding="utf-8"?>
+<p:notes xmlns:a="http://schemas.openxmlformats.org/drawingml/2006/main" xmlns:r="http://schemas.openxmlformats.org/officeDocument/2006/relationships" xmlns:p="http://schemas.openxmlformats.org/presentationml/2006/main">
+  <p:cSld>
+    <p:spTree>
+      <p:nvGrpSpPr>
+        <p:cNvPr id="1" name=""/>
+        <p:cNvGrpSpPr/>
+        <p:nvPr/>
+      </p:nvGrpSpPr>
+      <p:grpSpPr>
+        <a:xfrm>
+          <a:off x="0" y="0"/>
+          <a:ext cx="0" cy="0"/>
+          <a:chOff x="0" y="0"/>
+          <a:chExt cx="0" cy="0"/>
+        </a:xfrm>
+      </p:grpSpPr>
+      <p:sp>
+        <p:nvSpPr>
+          <p:cNvPr id="2" name="Marcador de imagen de diapositiva 1"/>
+          <p:cNvSpPr>
+            <a:spLocks noGrp="1" noRot="1" noChangeAspect="1"/>
+          </p:cNvSpPr>
+          <p:nvPr>
+            <p:ph type="sldImg"/>
+          </p:nvPr>
+        </p:nvSpPr>
+        <p:spPr/>
+        <p:txBody>
+          <a:bodyPr/>
+          <a:lstStyle/>
+          <a:p>
+            <a:endParaRPr lang="es-ES" dirty="0"/>
+          </a:p>
+        </p:txBody>
+      </p:sp>
+      <p:sp>
+        <p:nvSpPr>
+          <p:cNvPr id="3" name="Marcador de notas 2"/>
+          <p:cNvSpPr>
+            <a:spLocks noGrp="1"/>
+          </p:cNvSpPr>
+          <p:nvPr>
+            <p:ph type="body" idx="1"/>
+          </p:nvPr>
+        </p:nvSpPr>
+        <p:spPr/>
+        <p:txBody>
+          <a:bodyPr/>
+          <a:lstStyle/>
+          <a:p>
+            <a:endParaRPr lang="es-ES" dirty="0"/>
+          </a:p>
+        </p:txBody>
+      </p:sp>
+      <p:sp>
+        <p:nvSpPr>
+          <p:cNvPr id="4" name="Marcador de número de diapositiva 3"/>
+          <p:cNvSpPr>
+            <a:spLocks noGrp="1"/>
+          </p:cNvSpPr>
+          <p:nvPr>
+            <p:ph type="sldNum" sz="quarter" idx="10"/>
+          </p:nvPr>
+        </p:nvSpPr>
+        <p:spPr/>
+        <p:txBody>
+          <a:bodyPr/>
+          <a:lstStyle/>
+          <a:p>
+            <a:fld id="{05D135E5-457A-4183-A722-09BD01DC1252}" type="slidenum">
+              <a:rPr lang="es-ES" smtClean="0"/>
+              <a:t>15</a:t>
             </a:fld>
             <a:endParaRPr lang="es-ES" dirty="0"/>
           </a:p>
@@ -996,7 +1320,29 @@
           <a:bodyPr/>
           <a:lstStyle/>
           <a:p>
-            <a:endParaRPr lang="es-ES"/>
+            <a:pPr marL="171450" indent="-171450">
+              <a:buFontTx/>
+              <a:buChar char="-"/>
+            </a:pPr>
+            <a:r>
+              <a:rPr lang="es-ES" dirty="0"/>
+              <a:t>Morado -&gt; Métodos Híbridos (Detección + Segmentación)</a:t>
+            </a:r>
+          </a:p>
+          <a:p>
+            <a:pPr marL="171450" indent="-171450">
+              <a:buFontTx/>
+              <a:buChar char="-"/>
+            </a:pPr>
+            <a:r>
+              <a:rPr lang="es-ES" dirty="0"/>
+              <a:t>Naranja -&gt; Calibración/</a:t>
+            </a:r>
+            <a:r>
+              <a:rPr lang="es-ES" dirty="0" err="1"/>
+              <a:t>Geomtería</a:t>
+            </a:r>
+            <a:endParaRPr lang="es-ES" dirty="0"/>
           </a:p>
         </p:txBody>
       </p:sp>
@@ -1156,6 +1502,121 @@
   <p:cSld>
     <p:spTree>
       <p:nvGrpSpPr>
+        <p:cNvPr id="1" name="">
+          <a:extLst>
+            <a:ext uri="{FF2B5EF4-FFF2-40B4-BE49-F238E27FC236}">
+              <a16:creationId xmlns:a16="http://schemas.microsoft.com/office/drawing/2014/main" id="{1683E4B4-2AD9-5E21-26AB-66ABCDF3D719}"/>
+            </a:ext>
+          </a:extLst>
+        </p:cNvPr>
+        <p:cNvGrpSpPr/>
+        <p:nvPr/>
+      </p:nvGrpSpPr>
+      <p:grpSpPr>
+        <a:xfrm>
+          <a:off x="0" y="0"/>
+          <a:ext cx="0" cy="0"/>
+          <a:chOff x="0" y="0"/>
+          <a:chExt cx="0" cy="0"/>
+        </a:xfrm>
+      </p:grpSpPr>
+      <p:sp>
+        <p:nvSpPr>
+          <p:cNvPr id="2" name="Marcador de imagen de diapositiva 1">
+            <a:extLst>
+              <a:ext uri="{FF2B5EF4-FFF2-40B4-BE49-F238E27FC236}">
+                <a16:creationId xmlns:a16="http://schemas.microsoft.com/office/drawing/2014/main" id="{8DBB4248-D368-6261-88B3-E392ADDA03A9}"/>
+              </a:ext>
+            </a:extLst>
+          </p:cNvPr>
+          <p:cNvSpPr>
+            <a:spLocks noGrp="1" noRot="1" noChangeAspect="1"/>
+          </p:cNvSpPr>
+          <p:nvPr>
+            <p:ph type="sldImg"/>
+          </p:nvPr>
+        </p:nvSpPr>
+        <p:spPr/>
+        <p:txBody>
+          <a:bodyPr/>
+          <a:lstStyle/>
+          <a:p>
+            <a:endParaRPr lang="es-ES" dirty="0"/>
+          </a:p>
+        </p:txBody>
+      </p:sp>
+      <p:sp>
+        <p:nvSpPr>
+          <p:cNvPr id="3" name="Marcador de notas 2">
+            <a:extLst>
+              <a:ext uri="{FF2B5EF4-FFF2-40B4-BE49-F238E27FC236}">
+                <a16:creationId xmlns:a16="http://schemas.microsoft.com/office/drawing/2014/main" id="{AB4BD80B-23D5-11C7-01A2-C039937E8D8E}"/>
+              </a:ext>
+            </a:extLst>
+          </p:cNvPr>
+          <p:cNvSpPr>
+            <a:spLocks noGrp="1"/>
+          </p:cNvSpPr>
+          <p:nvPr>
+            <p:ph type="body" idx="1"/>
+          </p:nvPr>
+        </p:nvSpPr>
+        <p:spPr/>
+        <p:txBody>
+          <a:bodyPr/>
+          <a:lstStyle/>
+          <a:p>
+            <a:endParaRPr lang="es-ES" dirty="0"/>
+          </a:p>
+        </p:txBody>
+      </p:sp>
+      <p:sp>
+        <p:nvSpPr>
+          <p:cNvPr id="4" name="Marcador de número de diapositiva 3">
+            <a:extLst>
+              <a:ext uri="{FF2B5EF4-FFF2-40B4-BE49-F238E27FC236}">
+                <a16:creationId xmlns:a16="http://schemas.microsoft.com/office/drawing/2014/main" id="{51570D81-D34D-8768-2617-AEB56BA0BB49}"/>
+              </a:ext>
+            </a:extLst>
+          </p:cNvPr>
+          <p:cNvSpPr>
+            <a:spLocks noGrp="1"/>
+          </p:cNvSpPr>
+          <p:nvPr>
+            <p:ph type="sldNum" sz="quarter" idx="10"/>
+          </p:nvPr>
+        </p:nvSpPr>
+        <p:spPr/>
+        <p:txBody>
+          <a:bodyPr/>
+          <a:lstStyle/>
+          <a:p>
+            <a:fld id="{05D135E5-457A-4183-A722-09BD01DC1252}" type="slidenum">
+              <a:rPr lang="es-ES" smtClean="0"/>
+              <a:t>7</a:t>
+            </a:fld>
+            <a:endParaRPr lang="es-ES" dirty="0"/>
+          </a:p>
+        </p:txBody>
+      </p:sp>
+    </p:spTree>
+    <p:extLst>
+      <p:ext uri="{BB962C8B-B14F-4D97-AF65-F5344CB8AC3E}">
+        <p14:creationId xmlns:p14="http://schemas.microsoft.com/office/powerpoint/2010/main" val="3525781236"/>
+      </p:ext>
+    </p:extLst>
+  </p:cSld>
+  <p:clrMapOvr>
+    <a:masterClrMapping/>
+  </p:clrMapOvr>
+</p:notes>
+</file>
+
+<file path=ppt/notesSlides/notesSlide6.xml><?xml version="1.0" encoding="utf-8"?>
+<p:notes xmlns:a="http://schemas.openxmlformats.org/drawingml/2006/main" xmlns:r="http://schemas.openxmlformats.org/officeDocument/2006/relationships" xmlns:p="http://schemas.openxmlformats.org/presentationml/2006/main">
+  <p:cSld>
+    <p:spTree>
+      <p:nvGrpSpPr>
         <p:cNvPr id="1" name=""/>
         <p:cNvGrpSpPr/>
         <p:nvPr/>
@@ -1223,7 +1684,7 @@
           <a:p>
             <a:fld id="{05D135E5-457A-4183-A722-09BD01DC1252}" type="slidenum">
               <a:rPr lang="es-ES" smtClean="0"/>
-              <a:t>7</a:t>
+              <a:t>8</a:t>
             </a:fld>
             <a:endParaRPr lang="es-ES" dirty="0"/>
           </a:p>
@@ -1242,7 +1703,7 @@
 </p:notes>
 </file>
 
-<file path=ppt/notesSlides/notesSlide6.xml><?xml version="1.0" encoding="utf-8"?>
+<file path=ppt/notesSlides/notesSlide7.xml><?xml version="1.0" encoding="utf-8"?>
 <p:notes xmlns:a="http://schemas.openxmlformats.org/drawingml/2006/main" xmlns:r="http://schemas.openxmlformats.org/officeDocument/2006/relationships" xmlns:p="http://schemas.openxmlformats.org/presentationml/2006/main">
   <p:cSld>
     <p:spTree>
@@ -1311,6 +1772,53 @@
           <a:bodyPr/>
           <a:lstStyle/>
           <a:p>
+            <a:pPr marL="171450" indent="-171450">
+              <a:buFontTx/>
+              <a:buChar char="-"/>
+            </a:pPr>
+            <a:r>
+              <a:rPr lang="es-ES" dirty="0" err="1"/>
+              <a:t>Grounding</a:t>
+            </a:r>
+            <a:r>
+              <a:rPr lang="es-ES" dirty="0"/>
+              <a:t> DINO -&gt; </a:t>
+            </a:r>
+            <a:r>
+              <a:rPr lang="es-ES" dirty="0" err="1"/>
+              <a:t>Object</a:t>
+            </a:r>
+            <a:r>
+              <a:rPr lang="es-ES" dirty="0"/>
+              <a:t> </a:t>
+            </a:r>
+            <a:r>
+              <a:rPr lang="es-ES" dirty="0" err="1"/>
+              <a:t>Detection</a:t>
+            </a:r>
+            <a:endParaRPr lang="es-ES" dirty="0"/>
+          </a:p>
+          <a:p>
+            <a:pPr marL="171450" indent="-171450">
+              <a:buFontTx/>
+              <a:buChar char="-"/>
+            </a:pPr>
+            <a:r>
+              <a:rPr lang="es-ES" dirty="0"/>
+              <a:t>SAM -&gt; precise </a:t>
+            </a:r>
+            <a:r>
+              <a:rPr lang="es-ES" dirty="0" err="1"/>
+              <a:t>segmentation</a:t>
+            </a:r>
+            <a:r>
+              <a:rPr lang="es-ES" dirty="0"/>
+              <a:t> </a:t>
+            </a:r>
+            <a:r>
+              <a:rPr lang="es-ES" dirty="0" err="1"/>
+              <a:t>masks</a:t>
+            </a:r>
             <a:endParaRPr lang="es-ES" dirty="0"/>
           </a:p>
         </p:txBody>
@@ -1338,7 +1846,7 @@
           <a:p>
             <a:fld id="{05D135E5-457A-4183-A722-09BD01DC1252}" type="slidenum">
               <a:rPr lang="es-ES" smtClean="0"/>
-              <a:t>8</a:t>
+              <a:t>9</a:t>
             </a:fld>
             <a:endParaRPr lang="es-ES" dirty="0"/>
           </a:p>
@@ -1357,7 +1865,7 @@
 </p:notes>
 </file>
 
-<file path=ppt/notesSlides/notesSlide7.xml><?xml version="1.0" encoding="utf-8"?>
+<file path=ppt/notesSlides/notesSlide8.xml><?xml version="1.0" encoding="utf-8"?>
 <p:notes xmlns:a="http://schemas.openxmlformats.org/drawingml/2006/main" xmlns:r="http://schemas.openxmlformats.org/officeDocument/2006/relationships" xmlns:p="http://schemas.openxmlformats.org/presentationml/2006/main">
   <p:cSld>
     <p:spTree>
@@ -1453,7 +1961,7 @@
           <a:p>
             <a:fld id="{05D135E5-457A-4183-A722-09BD01DC1252}" type="slidenum">
               <a:rPr lang="es-ES" smtClean="0"/>
-              <a:t>9</a:t>
+              <a:t>10</a:t>
             </a:fld>
             <a:endParaRPr lang="es-ES" dirty="0"/>
           </a:p>
@@ -1472,7 +1980,7 @@
 </p:notes>
 </file>
 
-<file path=ppt/notesSlides/notesSlide8.xml><?xml version="1.0" encoding="utf-8"?>
+<file path=ppt/notesSlides/notesSlide9.xml><?xml version="1.0" encoding="utf-8"?>
 <p:notes xmlns:a="http://schemas.openxmlformats.org/drawingml/2006/main" xmlns:r="http://schemas.openxmlformats.org/officeDocument/2006/relationships" xmlns:p="http://schemas.openxmlformats.org/presentationml/2006/main">
   <p:cSld>
     <p:spTree>
@@ -1568,7 +2076,7 @@
           <a:p>
             <a:fld id="{05D135E5-457A-4183-A722-09BD01DC1252}" type="slidenum">
               <a:rPr lang="es-ES" smtClean="0"/>
-              <a:t>10</a:t>
+              <a:t>11</a:t>
             </a:fld>
             <a:endParaRPr lang="es-ES" dirty="0"/>
           </a:p>
@@ -1578,97 +2086,6 @@
     <p:extLst>
       <p:ext uri="{BB962C8B-B14F-4D97-AF65-F5344CB8AC3E}">
         <p14:creationId xmlns:p14="http://schemas.microsoft.com/office/powerpoint/2010/main" val="2030771114"/>
-      </p:ext>
-    </p:extLst>
-  </p:cSld>
-  <p:clrMapOvr>
-    <a:masterClrMapping/>
-  </p:clrMapOvr>
-</p:notes>
-</file>
-
-<file path=ppt/notesSlides/notesSlide9.xml><?xml version="1.0" encoding="utf-8"?>
-<p:notes xmlns:a="http://schemas.openxmlformats.org/drawingml/2006/main" xmlns:r="http://schemas.openxmlformats.org/officeDocument/2006/relationships" xmlns:p="http://schemas.openxmlformats.org/presentationml/2006/main">
-  <p:cSld>
-    <p:spTree>
-      <p:nvGrpSpPr>
-        <p:cNvPr id="1" name=""/>
-        <p:cNvGrpSpPr/>
-        <p:nvPr/>
-      </p:nvGrpSpPr>
-      <p:grpSpPr>
-        <a:xfrm>
-          <a:off x="0" y="0"/>
-          <a:ext cx="0" cy="0"/>
-          <a:chOff x="0" y="0"/>
-          <a:chExt cx="0" cy="0"/>
-        </a:xfrm>
-      </p:grpSpPr>
-      <p:sp>
-        <p:nvSpPr>
-          <p:cNvPr id="2" name="Marcador de imagen de diapositiva 1"/>
-          <p:cNvSpPr>
-            <a:spLocks noGrp="1" noRot="1" noChangeAspect="1"/>
-          </p:cNvSpPr>
-          <p:nvPr>
-            <p:ph type="sldImg"/>
-          </p:nvPr>
-        </p:nvSpPr>
-        <p:spPr/>
-        <p:txBody>
-          <a:bodyPr/>
-          <a:lstStyle/>
-          <a:p>
-            <a:endParaRPr lang="es-ES" dirty="0"/>
-          </a:p>
-        </p:txBody>
-      </p:sp>
-      <p:sp>
-        <p:nvSpPr>
-          <p:cNvPr id="3" name="Marcador de notas 2"/>
-          <p:cNvSpPr>
-            <a:spLocks noGrp="1"/>
-          </p:cNvSpPr>
-          <p:nvPr>
-            <p:ph type="body" idx="1"/>
-          </p:nvPr>
-        </p:nvSpPr>
-        <p:spPr/>
-        <p:txBody>
-          <a:bodyPr/>
-          <a:lstStyle/>
-          <a:p>
-            <a:endParaRPr lang="es-ES" dirty="0"/>
-          </a:p>
-        </p:txBody>
-      </p:sp>
-      <p:sp>
-        <p:nvSpPr>
-          <p:cNvPr id="4" name="Marcador de número de diapositiva 3"/>
-          <p:cNvSpPr>
-            <a:spLocks noGrp="1"/>
-          </p:cNvSpPr>
-          <p:nvPr>
-            <p:ph type="sldNum" sz="quarter" idx="10"/>
-          </p:nvPr>
-        </p:nvSpPr>
-        <p:spPr/>
-        <p:txBody>
-          <a:bodyPr/>
-          <a:lstStyle/>
-          <a:p>
-            <a:fld id="{05D135E5-457A-4183-A722-09BD01DC1252}" type="slidenum">
-              <a:rPr lang="es-ES" smtClean="0"/>
-              <a:t>11</a:t>
-            </a:fld>
-            <a:endParaRPr lang="es-ES" dirty="0"/>
-          </a:p>
-        </p:txBody>
-      </p:sp>
-    </p:spTree>
-    <p:extLst>
-      <p:ext uri="{BB962C8B-B14F-4D97-AF65-F5344CB8AC3E}">
-        <p14:creationId xmlns:p14="http://schemas.microsoft.com/office/powerpoint/2010/main" val="556698752"/>
       </p:ext>
     </p:extLst>
   </p:cSld>
@@ -3035,14 +3452,11 @@
           <a:lstStyle/>
           <a:p>
             <a:pPr algn="l"/>
-            <a:r>
-              <a:rPr lang="en-US" dirty="0">
-                <a:solidFill>
-                  <a:srgbClr val="FF0000"/>
-                </a:solidFill>
-              </a:rPr>
-              <a:t>Title - For example: Phishing detection using Phishing kits</a:t>
-            </a:r>
+            <a:endParaRPr lang="en-US" dirty="0">
+              <a:solidFill>
+                <a:srgbClr val="FF0000"/>
+              </a:solidFill>
+            </a:endParaRPr>
           </a:p>
         </p:txBody>
       </p:sp>
@@ -3105,8 +3519,8 @@
         </p:nvSpPr>
         <p:spPr>
           <a:xfrm>
-            <a:off x="5251466" y="3774503"/>
-            <a:ext cx="3492374" cy="564342"/>
+            <a:off x="5251466" y="3774502"/>
+            <a:ext cx="3492374" cy="1601061"/>
           </a:xfrm>
           <a:prstGeom prst="rect">
             <a:avLst/>
@@ -3265,7 +3679,7 @@
                   </a:schemeClr>
                 </a:solidFill>
               </a:rPr>
-              <a:t>by Student Name</a:t>
+              <a:t>Jaime Alvarado Fernández</a:t>
             </a:r>
           </a:p>
           <a:p>
@@ -3280,7 +3694,69 @@
                   </a:schemeClr>
                 </a:solidFill>
               </a:rPr>
-              <a:t>Presentation date</a:t>
+              <a:t>David Morán </a:t>
+            </a:r>
+            <a:r>
+              <a:rPr lang="en-GB" sz="1200" dirty="0" err="1">
+                <a:solidFill>
+                  <a:schemeClr val="bg1">
+                    <a:lumMod val="75000"/>
+                  </a:schemeClr>
+                </a:solidFill>
+              </a:rPr>
+              <a:t>Gorgojo</a:t>
+            </a:r>
+            <a:endParaRPr lang="en-GB" sz="1200" dirty="0">
+              <a:solidFill>
+                <a:schemeClr val="bg1">
+                  <a:lumMod val="75000"/>
+                </a:schemeClr>
+              </a:solidFill>
+            </a:endParaRPr>
+          </a:p>
+          <a:p>
+            <a:pPr marL="0" indent="0" algn="r">
+              <a:buNone/>
+            </a:pPr>
+            <a:r>
+              <a:rPr lang="en-GB" sz="1200" dirty="0">
+                <a:solidFill>
+                  <a:schemeClr val="bg1">
+                    <a:lumMod val="75000"/>
+                  </a:schemeClr>
+                </a:solidFill>
+              </a:rPr>
+              <a:t>Pablo Ruíz Morán</a:t>
+            </a:r>
+          </a:p>
+          <a:p>
+            <a:pPr marL="0" indent="0" algn="r">
+              <a:buNone/>
+            </a:pPr>
+            <a:r>
+              <a:rPr lang="en-GB" sz="1200" dirty="0">
+                <a:solidFill>
+                  <a:schemeClr val="bg1">
+                    <a:lumMod val="75000"/>
+                  </a:schemeClr>
+                </a:solidFill>
+              </a:rPr>
+              <a:t>Miguel Sánchez Rodríguez</a:t>
+            </a:r>
+          </a:p>
+          <a:p>
+            <a:pPr marL="0" indent="0" algn="r">
+              <a:buNone/>
+            </a:pPr>
+            <a:r>
+              <a:rPr lang="en-GB" sz="1200" dirty="0">
+                <a:solidFill>
+                  <a:schemeClr val="bg1">
+                    <a:lumMod val="75000"/>
+                  </a:schemeClr>
+                </a:solidFill>
+              </a:rPr>
+              <a:t>15/03/2026</a:t>
             </a:r>
           </a:p>
           <a:p>
@@ -3354,6 +3830,136 @@
         <p:cNvPr id="1" name="">
           <a:extLst>
             <a:ext uri="{FF2B5EF4-FFF2-40B4-BE49-F238E27FC236}">
+              <a16:creationId xmlns:a16="http://schemas.microsoft.com/office/drawing/2014/main" id="{F4CD17D0-6AE0-335D-DCCB-779C22440197}"/>
+            </a:ext>
+          </a:extLst>
+        </p:cNvPr>
+        <p:cNvGrpSpPr/>
+        <p:nvPr/>
+      </p:nvGrpSpPr>
+      <p:grpSpPr>
+        <a:xfrm>
+          <a:off x="0" y="0"/>
+          <a:ext cx="0" cy="0"/>
+          <a:chOff x="0" y="0"/>
+          <a:chExt cx="0" cy="0"/>
+        </a:xfrm>
+      </p:grpSpPr>
+      <p:sp>
+        <p:nvSpPr>
+          <p:cNvPr id="2" name="Title 1">
+            <a:extLst>
+              <a:ext uri="{FF2B5EF4-FFF2-40B4-BE49-F238E27FC236}">
+                <a16:creationId xmlns:a16="http://schemas.microsoft.com/office/drawing/2014/main" id="{ABE9FD54-E3E9-1AA0-9DD9-0517F99B7216}"/>
+              </a:ext>
+            </a:extLst>
+          </p:cNvPr>
+          <p:cNvSpPr>
+            <a:spLocks noGrp="1"/>
+          </p:cNvSpPr>
+          <p:nvPr>
+            <p:ph type="title"/>
+          </p:nvPr>
+        </p:nvSpPr>
+        <p:spPr>
+          <a:xfrm>
+            <a:off x="457200" y="274638"/>
+            <a:ext cx="7302500" cy="788278"/>
+          </a:xfrm>
+        </p:spPr>
+        <p:txBody>
+          <a:bodyPr>
+            <a:normAutofit/>
+          </a:bodyPr>
+          <a:lstStyle/>
+          <a:p>
+            <a:pPr algn="l"/>
+            <a:r>
+              <a:rPr lang="en-GB" sz="2800" dirty="0"/>
+              <a:t>3. Selected method 03: ZZZZ</a:t>
+            </a:r>
+          </a:p>
+        </p:txBody>
+      </p:sp>
+      <p:sp>
+        <p:nvSpPr>
+          <p:cNvPr id="30" name="Rectangle 7">
+            <a:extLst>
+              <a:ext uri="{FF2B5EF4-FFF2-40B4-BE49-F238E27FC236}">
+                <a16:creationId xmlns:a16="http://schemas.microsoft.com/office/drawing/2014/main" id="{36C84E96-7653-5D12-E6C6-A76E4A341C6C}"/>
+              </a:ext>
+            </a:extLst>
+          </p:cNvPr>
+          <p:cNvSpPr/>
+          <p:nvPr/>
+        </p:nvSpPr>
+        <p:spPr>
+          <a:xfrm>
+            <a:off x="80137" y="66509"/>
+            <a:ext cx="6565636" cy="303085"/>
+          </a:xfrm>
+          <a:prstGeom prst="rect">
+            <a:avLst/>
+          </a:prstGeom>
+          <a:noFill/>
+          <a:ln>
+            <a:noFill/>
+          </a:ln>
+          <a:extLst>
+            <a:ext uri="{909E8E84-426E-40DD-AFC4-6F175D3DCCD1}">
+              <a14:hiddenFill xmlns:a14="http://schemas.microsoft.com/office/drawing/2010/main">
+                <a:solidFill>
+                  <a:srgbClr val="FFFFFF"/>
+                </a:solidFill>
+              </a14:hiddenFill>
+            </a:ext>
+            <a:ext uri="{91240B29-F687-4F45-9708-019B960494DF}">
+              <a14:hiddenLine xmlns:a14="http://schemas.microsoft.com/office/drawing/2010/main" w="9525" cap="flat">
+                <a:solidFill>
+                  <a:srgbClr val="000000"/>
+                </a:solidFill>
+                <a:miter lim="800000"/>
+                <a:headEnd type="none" w="med" len="med"/>
+                <a:tailEnd type="none" w="med" len="med"/>
+              </a14:hiddenLine>
+            </a:ext>
+          </a:extLst>
+        </p:spPr>
+        <p:txBody>
+          <a:bodyPr lIns="0" tIns="0" rIns="0" bIns="0"/>
+          <a:lstStyle/>
+          <a:p>
+            <a:endParaRPr lang="en-US" sz="800" b="1" dirty="0">
+              <a:solidFill>
+                <a:srgbClr val="535353"/>
+              </a:solidFill>
+              <a:latin typeface="Geneva" charset="0"/>
+              <a:cs typeface="Geneva" charset="0"/>
+            </a:endParaRPr>
+          </a:p>
+        </p:txBody>
+      </p:sp>
+    </p:spTree>
+    <p:extLst>
+      <p:ext uri="{BB962C8B-B14F-4D97-AF65-F5344CB8AC3E}">
+        <p14:creationId xmlns:p14="http://schemas.microsoft.com/office/powerpoint/2010/main" val="2985104822"/>
+      </p:ext>
+    </p:extLst>
+  </p:cSld>
+  <p:clrMapOvr>
+    <a:masterClrMapping/>
+  </p:clrMapOvr>
+</p:sld>
+</file>
+
+<file path=ppt/slides/slide11.xml><?xml version="1.0" encoding="utf-8"?>
+<p:sld xmlns:a="http://schemas.openxmlformats.org/drawingml/2006/main" xmlns:r="http://schemas.openxmlformats.org/officeDocument/2006/relationships" xmlns:p="http://schemas.openxmlformats.org/presentationml/2006/main">
+  <p:cSld>
+    <p:spTree>
+      <p:nvGrpSpPr>
+        <p:cNvPr id="1" name="">
+          <a:extLst>
+            <a:ext uri="{FF2B5EF4-FFF2-40B4-BE49-F238E27FC236}">
               <a16:creationId xmlns:a16="http://schemas.microsoft.com/office/drawing/2014/main" id="{B47EF38C-1117-7442-9501-12F9402F6EE5}"/>
             </a:ext>
           </a:extLst>
@@ -3476,7 +4082,297 @@
 </p:sld>
 </file>
 
-<file path=ppt/slides/slide11.xml><?xml version="1.0" encoding="utf-8"?>
+<file path=ppt/slides/slide12.xml><?xml version="1.0" encoding="utf-8"?>
+<p:sld xmlns:a="http://schemas.openxmlformats.org/drawingml/2006/main" xmlns:r="http://schemas.openxmlformats.org/officeDocument/2006/relationships" xmlns:p="http://schemas.openxmlformats.org/presentationml/2006/main">
+  <p:cSld>
+    <p:spTree>
+      <p:nvGrpSpPr>
+        <p:cNvPr id="1" name="">
+          <a:extLst>
+            <a:ext uri="{FF2B5EF4-FFF2-40B4-BE49-F238E27FC236}">
+              <a16:creationId xmlns:a16="http://schemas.microsoft.com/office/drawing/2014/main" id="{C5558EEF-EC96-D69C-B8E5-BD64FE03A695}"/>
+            </a:ext>
+          </a:extLst>
+        </p:cNvPr>
+        <p:cNvGrpSpPr/>
+        <p:nvPr/>
+      </p:nvGrpSpPr>
+      <p:grpSpPr>
+        <a:xfrm>
+          <a:off x="0" y="0"/>
+          <a:ext cx="0" cy="0"/>
+          <a:chOff x="0" y="0"/>
+          <a:chExt cx="0" cy="0"/>
+        </a:xfrm>
+      </p:grpSpPr>
+      <p:sp>
+        <p:nvSpPr>
+          <p:cNvPr id="2" name="Title 1">
+            <a:extLst>
+              <a:ext uri="{FF2B5EF4-FFF2-40B4-BE49-F238E27FC236}">
+                <a16:creationId xmlns:a16="http://schemas.microsoft.com/office/drawing/2014/main" id="{2B9BDD58-B60F-FD54-CD00-99A6A5898414}"/>
+              </a:ext>
+            </a:extLst>
+          </p:cNvPr>
+          <p:cNvSpPr>
+            <a:spLocks noGrp="1"/>
+          </p:cNvSpPr>
+          <p:nvPr>
+            <p:ph type="title"/>
+          </p:nvPr>
+        </p:nvSpPr>
+        <p:spPr>
+          <a:xfrm>
+            <a:off x="457200" y="274638"/>
+            <a:ext cx="7302500" cy="788278"/>
+          </a:xfrm>
+        </p:spPr>
+        <p:txBody>
+          <a:bodyPr>
+            <a:normAutofit/>
+          </a:bodyPr>
+          <a:lstStyle/>
+          <a:p>
+            <a:pPr algn="l"/>
+            <a:r>
+              <a:rPr lang="en-GB" sz="2800" dirty="0"/>
+              <a:t>4. Datasets </a:t>
+            </a:r>
+          </a:p>
+        </p:txBody>
+      </p:sp>
+      <p:sp>
+        <p:nvSpPr>
+          <p:cNvPr id="30" name="Rectangle 7">
+            <a:extLst>
+              <a:ext uri="{FF2B5EF4-FFF2-40B4-BE49-F238E27FC236}">
+                <a16:creationId xmlns:a16="http://schemas.microsoft.com/office/drawing/2014/main" id="{52A72436-A003-CA2F-05BA-D66E839936B3}"/>
+              </a:ext>
+            </a:extLst>
+          </p:cNvPr>
+          <p:cNvSpPr/>
+          <p:nvPr/>
+        </p:nvSpPr>
+        <p:spPr>
+          <a:xfrm>
+            <a:off x="80137" y="66509"/>
+            <a:ext cx="6565636" cy="303085"/>
+          </a:xfrm>
+          <a:prstGeom prst="rect">
+            <a:avLst/>
+          </a:prstGeom>
+          <a:noFill/>
+          <a:ln>
+            <a:noFill/>
+          </a:ln>
+          <a:extLst>
+            <a:ext uri="{909E8E84-426E-40DD-AFC4-6F175D3DCCD1}">
+              <a14:hiddenFill xmlns:a14="http://schemas.microsoft.com/office/drawing/2010/main">
+                <a:solidFill>
+                  <a:srgbClr val="FFFFFF"/>
+                </a:solidFill>
+              </a14:hiddenFill>
+            </a:ext>
+            <a:ext uri="{91240B29-F687-4F45-9708-019B960494DF}">
+              <a14:hiddenLine xmlns:a14="http://schemas.microsoft.com/office/drawing/2010/main" w="9525" cap="flat">
+                <a:solidFill>
+                  <a:srgbClr val="000000"/>
+                </a:solidFill>
+                <a:miter lim="800000"/>
+                <a:headEnd type="none" w="med" len="med"/>
+                <a:tailEnd type="none" w="med" len="med"/>
+              </a14:hiddenLine>
+            </a:ext>
+          </a:extLst>
+        </p:spPr>
+        <p:txBody>
+          <a:bodyPr lIns="0" tIns="0" rIns="0" bIns="0"/>
+          <a:lstStyle/>
+          <a:p>
+            <a:endParaRPr lang="en-US" sz="800" b="1" dirty="0">
+              <a:solidFill>
+                <a:srgbClr val="535353"/>
+              </a:solidFill>
+              <a:latin typeface="Geneva" charset="0"/>
+              <a:cs typeface="Geneva" charset="0"/>
+            </a:endParaRPr>
+          </a:p>
+        </p:txBody>
+      </p:sp>
+      <p:pic>
+        <p:nvPicPr>
+          <p:cNvPr id="4" name="Imagen 3">
+            <a:extLst>
+              <a:ext uri="{FF2B5EF4-FFF2-40B4-BE49-F238E27FC236}">
+                <a16:creationId xmlns:a16="http://schemas.microsoft.com/office/drawing/2014/main" id="{B4E22E7E-51E3-8075-D64E-9C8AF62CADB4}"/>
+              </a:ext>
+            </a:extLst>
+          </p:cNvPr>
+          <p:cNvPicPr>
+            <a:picLocks noChangeAspect="1"/>
+          </p:cNvPicPr>
+          <p:nvPr/>
+        </p:nvPicPr>
+        <p:blipFill>
+          <a:blip r:embed="rId3"/>
+          <a:stretch>
+            <a:fillRect/>
+          </a:stretch>
+        </p:blipFill>
+        <p:spPr>
+          <a:xfrm>
+            <a:off x="274401" y="1908266"/>
+            <a:ext cx="8595198" cy="2738621"/>
+          </a:xfrm>
+          <a:prstGeom prst="rect">
+            <a:avLst/>
+          </a:prstGeom>
+        </p:spPr>
+      </p:pic>
+    </p:spTree>
+    <p:extLst>
+      <p:ext uri="{BB962C8B-B14F-4D97-AF65-F5344CB8AC3E}">
+        <p14:creationId xmlns:p14="http://schemas.microsoft.com/office/powerpoint/2010/main" val="3100511610"/>
+      </p:ext>
+    </p:extLst>
+  </p:cSld>
+  <p:clrMapOvr>
+    <a:masterClrMapping/>
+  </p:clrMapOvr>
+</p:sld>
+</file>
+
+<file path=ppt/slides/slide13.xml><?xml version="1.0" encoding="utf-8"?>
+<p:sld xmlns:a="http://schemas.openxmlformats.org/drawingml/2006/main" xmlns:r="http://schemas.openxmlformats.org/officeDocument/2006/relationships" xmlns:p="http://schemas.openxmlformats.org/presentationml/2006/main">
+  <p:cSld>
+    <p:spTree>
+      <p:nvGrpSpPr>
+        <p:cNvPr id="1" name="">
+          <a:extLst>
+            <a:ext uri="{FF2B5EF4-FFF2-40B4-BE49-F238E27FC236}">
+              <a16:creationId xmlns:a16="http://schemas.microsoft.com/office/drawing/2014/main" id="{9E86E997-3538-A49B-7E42-C15AFC38E4E5}"/>
+            </a:ext>
+          </a:extLst>
+        </p:cNvPr>
+        <p:cNvGrpSpPr/>
+        <p:nvPr/>
+      </p:nvGrpSpPr>
+      <p:grpSpPr>
+        <a:xfrm>
+          <a:off x="0" y="0"/>
+          <a:ext cx="0" cy="0"/>
+          <a:chOff x="0" y="0"/>
+          <a:chExt cx="0" cy="0"/>
+        </a:xfrm>
+      </p:grpSpPr>
+      <p:sp>
+        <p:nvSpPr>
+          <p:cNvPr id="2" name="Title 1">
+            <a:extLst>
+              <a:ext uri="{FF2B5EF4-FFF2-40B4-BE49-F238E27FC236}">
+                <a16:creationId xmlns:a16="http://schemas.microsoft.com/office/drawing/2014/main" id="{FCCC4654-C0D8-35E6-FFE3-2CA8A0583EB0}"/>
+              </a:ext>
+            </a:extLst>
+          </p:cNvPr>
+          <p:cNvSpPr>
+            <a:spLocks noGrp="1"/>
+          </p:cNvSpPr>
+          <p:nvPr>
+            <p:ph type="title"/>
+          </p:nvPr>
+        </p:nvSpPr>
+        <p:spPr>
+          <a:xfrm>
+            <a:off x="457200" y="274638"/>
+            <a:ext cx="7302500" cy="788278"/>
+          </a:xfrm>
+        </p:spPr>
+        <p:txBody>
+          <a:bodyPr>
+            <a:normAutofit/>
+          </a:bodyPr>
+          <a:lstStyle/>
+          <a:p>
+            <a:pPr algn="l"/>
+            <a:r>
+              <a:rPr lang="en-GB" sz="2800" dirty="0"/>
+              <a:t>5. Performance Metrics</a:t>
+            </a:r>
+          </a:p>
+        </p:txBody>
+      </p:sp>
+      <p:sp>
+        <p:nvSpPr>
+          <p:cNvPr id="30" name="Rectangle 7">
+            <a:extLst>
+              <a:ext uri="{FF2B5EF4-FFF2-40B4-BE49-F238E27FC236}">
+                <a16:creationId xmlns:a16="http://schemas.microsoft.com/office/drawing/2014/main" id="{0CE30BE0-5015-91ED-40F7-A8727B8688D9}"/>
+              </a:ext>
+            </a:extLst>
+          </p:cNvPr>
+          <p:cNvSpPr/>
+          <p:nvPr/>
+        </p:nvSpPr>
+        <p:spPr>
+          <a:xfrm>
+            <a:off x="80137" y="66509"/>
+            <a:ext cx="6565636" cy="303085"/>
+          </a:xfrm>
+          <a:prstGeom prst="rect">
+            <a:avLst/>
+          </a:prstGeom>
+          <a:noFill/>
+          <a:ln>
+            <a:noFill/>
+          </a:ln>
+          <a:extLst>
+            <a:ext uri="{909E8E84-426E-40DD-AFC4-6F175D3DCCD1}">
+              <a14:hiddenFill xmlns:a14="http://schemas.microsoft.com/office/drawing/2010/main">
+                <a:solidFill>
+                  <a:srgbClr val="FFFFFF"/>
+                </a:solidFill>
+              </a14:hiddenFill>
+            </a:ext>
+            <a:ext uri="{91240B29-F687-4F45-9708-019B960494DF}">
+              <a14:hiddenLine xmlns:a14="http://schemas.microsoft.com/office/drawing/2010/main" w="9525" cap="flat">
+                <a:solidFill>
+                  <a:srgbClr val="000000"/>
+                </a:solidFill>
+                <a:miter lim="800000"/>
+                <a:headEnd type="none" w="med" len="med"/>
+                <a:tailEnd type="none" w="med" len="med"/>
+              </a14:hiddenLine>
+            </a:ext>
+          </a:extLst>
+        </p:spPr>
+        <p:txBody>
+          <a:bodyPr lIns="0" tIns="0" rIns="0" bIns="0"/>
+          <a:lstStyle/>
+          <a:p>
+            <a:endParaRPr lang="en-US" sz="800" b="1" dirty="0">
+              <a:solidFill>
+                <a:srgbClr val="535353"/>
+              </a:solidFill>
+              <a:latin typeface="Geneva" charset="0"/>
+              <a:cs typeface="Geneva" charset="0"/>
+            </a:endParaRPr>
+          </a:p>
+        </p:txBody>
+      </p:sp>
+    </p:spTree>
+    <p:extLst>
+      <p:ext uri="{BB962C8B-B14F-4D97-AF65-F5344CB8AC3E}">
+        <p14:creationId xmlns:p14="http://schemas.microsoft.com/office/powerpoint/2010/main" val="2911866555"/>
+      </p:ext>
+    </p:extLst>
+  </p:cSld>
+  <p:clrMapOvr>
+    <a:masterClrMapping/>
+  </p:clrMapOvr>
+</p:sld>
+</file>
+
+<file path=ppt/slides/slide14.xml><?xml version="1.0" encoding="utf-8"?>
 <p:sld xmlns:a="http://schemas.openxmlformats.org/drawingml/2006/main" xmlns:r="http://schemas.openxmlformats.org/officeDocument/2006/relationships" xmlns:p="http://schemas.openxmlformats.org/presentationml/2006/main">
   <p:cSld>
     <p:spTree>
@@ -3551,14 +4447,14 @@
           </a:ln>
           <a:extLst>
             <a:ext uri="{909E8E84-426E-40dd-AFC4-6F175D3DCCD1}">
-              <a14:hiddenFill xmlns="" xmlns:a14="http://schemas.microsoft.com/office/drawing/2010/main">
+              <a14:hiddenFill xmlns:a14="http://schemas.microsoft.com/office/drawing/2010/main" xmlns="">
                 <a:solidFill>
                   <a:srgbClr val="FFFFFF"/>
                 </a:solidFill>
               </a14:hiddenFill>
             </a:ext>
             <a:ext uri="{91240B29-F687-4f45-9708-019B960494DF}">
-              <a14:hiddenLine xmlns="" xmlns:a14="http://schemas.microsoft.com/office/drawing/2010/main" w="9525">
+              <a14:hiddenLine xmlns:a14="http://schemas.microsoft.com/office/drawing/2010/main" xmlns="" w="9525">
                 <a:solidFill>
                   <a:srgbClr val="000000"/>
                 </a:solidFill>
@@ -3773,7 +4669,7 @@
 </p:sld>
 </file>
 
-<file path=ppt/slides/slide12.xml><?xml version="1.0" encoding="utf-8"?>
+<file path=ppt/slides/slide15.xml><?xml version="1.0" encoding="utf-8"?>
 <p:sld xmlns:a="http://schemas.openxmlformats.org/drawingml/2006/main" xmlns:r="http://schemas.openxmlformats.org/officeDocument/2006/relationships" xmlns:p="http://schemas.openxmlformats.org/presentationml/2006/main">
   <p:cSld>
     <p:spTree>
@@ -3941,7 +4837,7 @@
 </p:sld>
 </file>
 
-<file path=ppt/slides/slide13.xml><?xml version="1.0" encoding="utf-8"?>
+<file path=ppt/slides/slide16.xml><?xml version="1.0" encoding="utf-8"?>
 <p:sld xmlns:a="http://schemas.openxmlformats.org/drawingml/2006/main" xmlns:r="http://schemas.openxmlformats.org/officeDocument/2006/relationships" xmlns:p="http://schemas.openxmlformats.org/presentationml/2006/main">
   <p:cSld>
     <p:spTree>
@@ -3980,14 +4876,14 @@
           </a:ln>
           <a:extLst>
             <a:ext uri="{909E8E84-426E-40dd-AFC4-6F175D3DCCD1}">
-              <a14:hiddenFill xmlns:a14="http://schemas.microsoft.com/office/drawing/2010/main" xmlns="">
+              <a14:hiddenFill xmlns="" xmlns:a14="http://schemas.microsoft.com/office/drawing/2010/main">
                 <a:solidFill>
                   <a:srgbClr val="FFFFFF"/>
                 </a:solidFill>
               </a14:hiddenFill>
             </a:ext>
             <a:ext uri="{91240B29-F687-4f45-9708-019B960494DF}">
-              <a14:hiddenLine xmlns:a14="http://schemas.microsoft.com/office/drawing/2010/main" xmlns="" w="9525">
+              <a14:hiddenLine xmlns="" xmlns:a14="http://schemas.microsoft.com/office/drawing/2010/main" w="9525">
                 <a:solidFill>
                   <a:srgbClr val="000000"/>
                 </a:solidFill>
@@ -4442,14 +5338,14 @@
           </a:ln>
           <a:extLst>
             <a:ext uri="{909E8E84-426E-40dd-AFC4-6F175D3DCCD1}">
-              <a14:hiddenFill xmlns="" xmlns:a14="http://schemas.microsoft.com/office/drawing/2010/main">
+              <a14:hiddenFill xmlns:a14="http://schemas.microsoft.com/office/drawing/2010/main" xmlns="">
                 <a:solidFill>
                   <a:srgbClr val="FFFFFF"/>
                 </a:solidFill>
               </a14:hiddenFill>
             </a:ext>
             <a:ext uri="{91240B29-F687-4f45-9708-019B960494DF}">
-              <a14:hiddenLine xmlns="" xmlns:a14="http://schemas.microsoft.com/office/drawing/2010/main" w="9525">
+              <a14:hiddenLine xmlns:a14="http://schemas.microsoft.com/office/drawing/2010/main" xmlns="" w="9525">
                 <a:solidFill>
                   <a:srgbClr val="000000"/>
                 </a:solidFill>
@@ -4687,14 +5583,14 @@
           </a:ln>
           <a:extLst>
             <a:ext uri="{909E8E84-426E-40dd-AFC4-6F175D3DCCD1}">
-              <a14:hiddenFill xmlns="" xmlns:a14="http://schemas.microsoft.com/office/drawing/2010/main">
+              <a14:hiddenFill xmlns:a14="http://schemas.microsoft.com/office/drawing/2010/main" xmlns="">
                 <a:solidFill>
                   <a:srgbClr val="FFFFFF"/>
                 </a:solidFill>
               </a14:hiddenFill>
             </a:ext>
             <a:ext uri="{91240B29-F687-4f45-9708-019B960494DF}">
-              <a14:hiddenLine xmlns="" xmlns:a14="http://schemas.microsoft.com/office/drawing/2010/main" w="9525">
+              <a14:hiddenLine xmlns:a14="http://schemas.microsoft.com/office/drawing/2010/main" xmlns="" w="9525">
                 <a:solidFill>
                   <a:srgbClr val="000000"/>
                 </a:solidFill>
@@ -4947,14 +5843,14 @@
           </a:ln>
           <a:extLst>
             <a:ext uri="{909E8E84-426E-40dd-AFC4-6F175D3DCCD1}">
-              <a14:hiddenFill xmlns:a14="http://schemas.microsoft.com/office/drawing/2010/main" xmlns="">
+              <a14:hiddenFill xmlns="" xmlns:a14="http://schemas.microsoft.com/office/drawing/2010/main">
                 <a:solidFill>
                   <a:srgbClr val="FFFFFF"/>
                 </a:solidFill>
               </a14:hiddenFill>
             </a:ext>
             <a:ext uri="{91240B29-F687-4f45-9708-019B960494DF}">
-              <a14:hiddenLine xmlns:a14="http://schemas.microsoft.com/office/drawing/2010/main" xmlns="" w="9525">
+              <a14:hiddenLine xmlns="" xmlns:a14="http://schemas.microsoft.com/office/drawing/2010/main" w="9525">
                 <a:solidFill>
                   <a:srgbClr val="000000"/>
                 </a:solidFill>
@@ -5072,14 +5968,14 @@
             </a:ln>
             <a:extLst>
               <a:ext uri="{909E8E84-426E-40dd-AFC4-6F175D3DCCD1}">
-                <a14:hiddenFill xmlns:a14="http://schemas.microsoft.com/office/drawing/2010/main" xmlns="">
+                <a14:hiddenFill xmlns="" xmlns:a14="http://schemas.microsoft.com/office/drawing/2010/main">
                   <a:solidFill>
                     <a:srgbClr val="FFFFFF"/>
                   </a:solidFill>
                 </a14:hiddenFill>
               </a:ext>
               <a:ext uri="{91240B29-F687-4f45-9708-019B960494DF}">
-                <a14:hiddenLine xmlns:a14="http://schemas.microsoft.com/office/drawing/2010/main" xmlns="" w="9525">
+                <a14:hiddenLine xmlns="" xmlns:a14="http://schemas.microsoft.com/office/drawing/2010/main" w="9525">
                   <a:solidFill>
                     <a:srgbClr val="000000"/>
                   </a:solidFill>
@@ -5198,14 +6094,14 @@
             </a:ln>
             <a:extLst>
               <a:ext uri="{909E8E84-426E-40dd-AFC4-6F175D3DCCD1}">
-                <a14:hiddenFill xmlns:a14="http://schemas.microsoft.com/office/drawing/2010/main" xmlns="">
+                <a14:hiddenFill xmlns="" xmlns:a14="http://schemas.microsoft.com/office/drawing/2010/main">
                   <a:solidFill>
                     <a:srgbClr val="FFFFFF"/>
                   </a:solidFill>
                 </a14:hiddenFill>
               </a:ext>
               <a:ext uri="{91240B29-F687-4f45-9708-019B960494DF}">
-                <a14:hiddenLine xmlns:a14="http://schemas.microsoft.com/office/drawing/2010/main" xmlns="" w="9525">
+                <a14:hiddenLine xmlns="" xmlns:a14="http://schemas.microsoft.com/office/drawing/2010/main" w="9525">
                   <a:solidFill>
                     <a:srgbClr val="000000"/>
                   </a:solidFill>
@@ -5333,14 +6229,14 @@
             </a:ln>
             <a:extLst>
               <a:ext uri="{909E8E84-426E-40dd-AFC4-6F175D3DCCD1}">
-                <a14:hiddenFill xmlns:a14="http://schemas.microsoft.com/office/drawing/2010/main" xmlns="">
+                <a14:hiddenFill xmlns="" xmlns:a14="http://schemas.microsoft.com/office/drawing/2010/main">
                   <a:solidFill>
                     <a:srgbClr val="FFFFFF"/>
                   </a:solidFill>
                 </a14:hiddenFill>
               </a:ext>
               <a:ext uri="{91240B29-F687-4f45-9708-019B960494DF}">
-                <a14:hiddenLine xmlns:a14="http://schemas.microsoft.com/office/drawing/2010/main" xmlns="" w="9525">
+                <a14:hiddenLine xmlns="" xmlns:a14="http://schemas.microsoft.com/office/drawing/2010/main" w="9525">
                   <a:solidFill>
                     <a:srgbClr val="000000"/>
                   </a:solidFill>
@@ -5463,14 +6359,14 @@
             </a:ln>
             <a:extLst>
               <a:ext uri="{909E8E84-426E-40dd-AFC4-6F175D3DCCD1}">
-                <a14:hiddenFill xmlns:a14="http://schemas.microsoft.com/office/drawing/2010/main" xmlns="">
+                <a14:hiddenFill xmlns="" xmlns:a14="http://schemas.microsoft.com/office/drawing/2010/main">
                   <a:solidFill>
                     <a:srgbClr val="FFFFFF"/>
                   </a:solidFill>
                 </a14:hiddenFill>
               </a:ext>
               <a:ext uri="{91240B29-F687-4f45-9708-019B960494DF}">
-                <a14:hiddenLine xmlns:a14="http://schemas.microsoft.com/office/drawing/2010/main" xmlns="" w="9525">
+                <a14:hiddenLine xmlns="" xmlns:a14="http://schemas.microsoft.com/office/drawing/2010/main" w="9525">
                   <a:solidFill>
                     <a:srgbClr val="000000"/>
                   </a:solidFill>
@@ -5589,14 +6485,14 @@
             </a:ln>
             <a:extLst>
               <a:ext uri="{909E8E84-426E-40dd-AFC4-6F175D3DCCD1}">
-                <a14:hiddenFill xmlns:a14="http://schemas.microsoft.com/office/drawing/2010/main" xmlns="">
+                <a14:hiddenFill xmlns="" xmlns:a14="http://schemas.microsoft.com/office/drawing/2010/main">
                   <a:solidFill>
                     <a:srgbClr val="FFFFFF"/>
                   </a:solidFill>
                 </a14:hiddenFill>
               </a:ext>
               <a:ext uri="{91240B29-F687-4f45-9708-019B960494DF}">
-                <a14:hiddenLine xmlns:a14="http://schemas.microsoft.com/office/drawing/2010/main" xmlns="" w="9525">
+                <a14:hiddenLine xmlns="" xmlns:a14="http://schemas.microsoft.com/office/drawing/2010/main" w="9525">
                   <a:solidFill>
                     <a:srgbClr val="000000"/>
                   </a:solidFill>
@@ -6158,14 +7054,46 @@
         </p:spPr>
         <p:txBody>
           <a:bodyPr>
-            <a:normAutofit/>
+            <a:normAutofit fontScale="90000"/>
           </a:bodyPr>
           <a:lstStyle/>
           <a:p>
             <a:pPr algn="l"/>
             <a:r>
               <a:rPr lang="en-GB" sz="2800" dirty="0"/>
-              <a:t>2. Literature review</a:t>
+              <a:t>2. Literature review (Una </a:t>
+            </a:r>
+            <a:r>
+              <a:rPr lang="en-GB" sz="2800" dirty="0" err="1"/>
+              <a:t>vez</a:t>
+            </a:r>
+            <a:r>
+              <a:rPr lang="en-GB" sz="2800" dirty="0"/>
+              <a:t> </a:t>
+            </a:r>
+            <a:r>
+              <a:rPr lang="en-GB" sz="2800" dirty="0" err="1"/>
+              <a:t>añadidos</a:t>
+            </a:r>
+            <a:r>
+              <a:rPr lang="en-GB" sz="2800" dirty="0"/>
+              <a:t> </a:t>
+            </a:r>
+            <a:r>
+              <a:rPr lang="en-GB" sz="2800" dirty="0" err="1"/>
+              <a:t>todos</a:t>
+            </a:r>
+            <a:r>
+              <a:rPr lang="en-GB" sz="2800" dirty="0"/>
+              <a:t> lo </a:t>
+            </a:r>
+            <a:r>
+              <a:rPr lang="en-GB" sz="2800" dirty="0" err="1"/>
+              <a:t>ajustamos</a:t>
+            </a:r>
+            <a:r>
+              <a:rPr lang="en-GB" sz="2800" dirty="0"/>
+              <a:t>)</a:t>
             </a:r>
           </a:p>
         </p:txBody>
@@ -7787,6 +8715,266 @@
   <p:cSld>
     <p:spTree>
       <p:nvGrpSpPr>
+        <p:cNvPr id="1" name="">
+          <a:extLst>
+            <a:ext uri="{FF2B5EF4-FFF2-40B4-BE49-F238E27FC236}">
+              <a16:creationId xmlns:a16="http://schemas.microsoft.com/office/drawing/2014/main" id="{DFE16D71-5974-0503-CBCB-9203F0549B41}"/>
+            </a:ext>
+          </a:extLst>
+        </p:cNvPr>
+        <p:cNvGrpSpPr/>
+        <p:nvPr/>
+      </p:nvGrpSpPr>
+      <p:grpSpPr>
+        <a:xfrm>
+          <a:off x="0" y="0"/>
+          <a:ext cx="0" cy="0"/>
+          <a:chOff x="0" y="0"/>
+          <a:chExt cx="0" cy="0"/>
+        </a:xfrm>
+      </p:grpSpPr>
+      <p:sp>
+        <p:nvSpPr>
+          <p:cNvPr id="2" name="Title 1">
+            <a:extLst>
+              <a:ext uri="{FF2B5EF4-FFF2-40B4-BE49-F238E27FC236}">
+                <a16:creationId xmlns:a16="http://schemas.microsoft.com/office/drawing/2014/main" id="{971E8495-DCDD-44BF-A761-F1C09DFC7E67}"/>
+              </a:ext>
+            </a:extLst>
+          </p:cNvPr>
+          <p:cNvSpPr>
+            <a:spLocks noGrp="1"/>
+          </p:cNvSpPr>
+          <p:nvPr>
+            <p:ph type="title"/>
+          </p:nvPr>
+        </p:nvSpPr>
+        <p:spPr>
+          <a:xfrm>
+            <a:off x="457200" y="274638"/>
+            <a:ext cx="7302500" cy="788278"/>
+          </a:xfrm>
+        </p:spPr>
+        <p:txBody>
+          <a:bodyPr>
+            <a:normAutofit/>
+          </a:bodyPr>
+          <a:lstStyle/>
+          <a:p>
+            <a:pPr algn="l"/>
+            <a:r>
+              <a:rPr lang="en-GB" sz="2800" b="1" dirty="0"/>
+              <a:t>2. Literature review – Deep Learning (Pablo)</a:t>
+            </a:r>
+          </a:p>
+        </p:txBody>
+      </p:sp>
+      <p:sp>
+        <p:nvSpPr>
+          <p:cNvPr id="30" name="Rectangle 7">
+            <a:extLst>
+              <a:ext uri="{FF2B5EF4-FFF2-40B4-BE49-F238E27FC236}">
+                <a16:creationId xmlns:a16="http://schemas.microsoft.com/office/drawing/2014/main" id="{E2998411-BBE1-1077-A886-49B61CE6AF93}"/>
+              </a:ext>
+            </a:extLst>
+          </p:cNvPr>
+          <p:cNvSpPr/>
+          <p:nvPr/>
+        </p:nvSpPr>
+        <p:spPr>
+          <a:xfrm>
+            <a:off x="80137" y="66509"/>
+            <a:ext cx="6565636" cy="303085"/>
+          </a:xfrm>
+          <a:prstGeom prst="rect">
+            <a:avLst/>
+          </a:prstGeom>
+          <a:noFill/>
+          <a:ln>
+            <a:noFill/>
+          </a:ln>
+          <a:extLst>
+            <a:ext uri="{909E8E84-426E-40DD-AFC4-6F175D3DCCD1}">
+              <a14:hiddenFill xmlns:a14="http://schemas.microsoft.com/office/drawing/2010/main">
+                <a:solidFill>
+                  <a:srgbClr val="FFFFFF"/>
+                </a:solidFill>
+              </a14:hiddenFill>
+            </a:ext>
+            <a:ext uri="{91240B29-F687-4F45-9708-019B960494DF}">
+              <a14:hiddenLine xmlns:a14="http://schemas.microsoft.com/office/drawing/2010/main" w="9525" cap="flat">
+                <a:solidFill>
+                  <a:srgbClr val="000000"/>
+                </a:solidFill>
+                <a:miter lim="800000"/>
+                <a:headEnd type="none" w="med" len="med"/>
+                <a:tailEnd type="none" w="med" len="med"/>
+              </a14:hiddenLine>
+            </a:ext>
+          </a:extLst>
+        </p:spPr>
+        <p:txBody>
+          <a:bodyPr lIns="0" tIns="0" rIns="0" bIns="0"/>
+          <a:lstStyle/>
+          <a:p>
+            <a:endParaRPr lang="en-US" sz="800" b="1" dirty="0">
+              <a:solidFill>
+                <a:srgbClr val="535353"/>
+              </a:solidFill>
+              <a:latin typeface="Geneva" charset="0"/>
+              <a:cs typeface="Geneva" charset="0"/>
+            </a:endParaRPr>
+          </a:p>
+        </p:txBody>
+      </p:sp>
+      <p:sp>
+        <p:nvSpPr>
+          <p:cNvPr id="32" name="CuadroTexto 31">
+            <a:extLst>
+              <a:ext uri="{FF2B5EF4-FFF2-40B4-BE49-F238E27FC236}">
+                <a16:creationId xmlns:a16="http://schemas.microsoft.com/office/drawing/2014/main" id="{F2551BD6-4841-68EE-055C-26F68C85CC3F}"/>
+              </a:ext>
+            </a:extLst>
+          </p:cNvPr>
+          <p:cNvSpPr txBox="1"/>
+          <p:nvPr/>
+        </p:nvSpPr>
+        <p:spPr>
+          <a:xfrm>
+            <a:off x="423164" y="1271045"/>
+            <a:ext cx="8414226" cy="415498"/>
+          </a:xfrm>
+          <a:prstGeom prst="rect">
+            <a:avLst/>
+          </a:prstGeom>
+          <a:noFill/>
+        </p:spPr>
+        <p:txBody>
+          <a:bodyPr wrap="none" rtlCol="0">
+            <a:spAutoFit/>
+          </a:bodyPr>
+          <a:lstStyle/>
+          <a:p>
+            <a:r>
+              <a:rPr lang="es-ES" sz="2000" b="1" dirty="0"/>
+              <a:t>Main method categories: </a:t>
+            </a:r>
+            <a:r>
+              <a:rPr lang="es-ES" sz="2100" b="1" dirty="0">
+                <a:solidFill>
+                  <a:schemeClr val="accent3">
+                    <a:lumMod val="75000"/>
+                  </a:schemeClr>
+                </a:solidFill>
+              </a:rPr>
+              <a:t>Segmentation</a:t>
+            </a:r>
+            <a:r>
+              <a:rPr lang="es-ES" sz="2000" dirty="0"/>
+              <a:t>,</a:t>
+            </a:r>
+            <a:r>
+              <a:rPr lang="es-ES" sz="2000" dirty="0">
+                <a:solidFill>
+                  <a:schemeClr val="tx2">
+                    <a:lumMod val="60000"/>
+                    <a:lumOff val="40000"/>
+                  </a:schemeClr>
+                </a:solidFill>
+              </a:rPr>
+              <a:t> </a:t>
+            </a:r>
+            <a:r>
+              <a:rPr lang="es-ES" sz="2100" b="1" dirty="0">
+                <a:solidFill>
+                  <a:schemeClr val="tx2">
+                    <a:lumMod val="60000"/>
+                    <a:lumOff val="40000"/>
+                  </a:schemeClr>
+                </a:solidFill>
+              </a:rPr>
+              <a:t>Detection</a:t>
+            </a:r>
+            <a:r>
+              <a:rPr lang="es-ES" sz="2000" b="1" dirty="0">
+                <a:solidFill>
+                  <a:schemeClr val="tx2">
+                    <a:lumMod val="60000"/>
+                    <a:lumOff val="40000"/>
+                  </a:schemeClr>
+                </a:solidFill>
+              </a:rPr>
+              <a:t> </a:t>
+            </a:r>
+            <a:r>
+              <a:rPr lang="es-ES" sz="2000" b="1" dirty="0"/>
+              <a:t>and</a:t>
+            </a:r>
+            <a:r>
+              <a:rPr lang="es-ES" sz="2000" dirty="0"/>
+              <a:t> </a:t>
+            </a:r>
+            <a:r>
+              <a:rPr lang="es-ES" sz="2100" b="1" dirty="0">
+                <a:solidFill>
+                  <a:schemeClr val="accent1">
+                    <a:lumMod val="75000"/>
+                  </a:schemeClr>
+                </a:solidFill>
+              </a:rPr>
+              <a:t>Anomaly Detection</a:t>
+            </a:r>
+            <a:endParaRPr lang="es-ES" sz="2100" b="1" dirty="0"/>
+          </a:p>
+        </p:txBody>
+      </p:sp>
+      <p:pic>
+        <p:nvPicPr>
+          <p:cNvPr id="36" name="Imagen 35">
+            <a:extLst>
+              <a:ext uri="{FF2B5EF4-FFF2-40B4-BE49-F238E27FC236}">
+                <a16:creationId xmlns:a16="http://schemas.microsoft.com/office/drawing/2014/main" id="{2AFB3648-5E3E-D6B1-A84A-32FA8CFFEB37}"/>
+              </a:ext>
+            </a:extLst>
+          </p:cNvPr>
+          <p:cNvPicPr>
+            <a:picLocks noChangeAspect="1"/>
+          </p:cNvPicPr>
+          <p:nvPr/>
+        </p:nvPicPr>
+        <p:blipFill>
+          <a:blip r:embed="rId3"/>
+          <a:srcRect/>
+          <a:stretch/>
+        </p:blipFill>
+        <p:spPr>
+          <a:xfrm>
+            <a:off x="331227" y="2552032"/>
+            <a:ext cx="8497957" cy="2542123"/>
+          </a:xfrm>
+          <a:prstGeom prst="rect">
+            <a:avLst/>
+          </a:prstGeom>
+        </p:spPr>
+      </p:pic>
+    </p:spTree>
+    <p:extLst>
+      <p:ext uri="{BB962C8B-B14F-4D97-AF65-F5344CB8AC3E}">
+        <p14:creationId xmlns:p14="http://schemas.microsoft.com/office/powerpoint/2010/main" val="3733304673"/>
+      </p:ext>
+    </p:extLst>
+  </p:cSld>
+  <p:clrMapOvr>
+    <a:masterClrMapping/>
+  </p:clrMapOvr>
+</p:sld>
+</file>
+
+<file path=ppt/slides/slide8.xml><?xml version="1.0" encoding="utf-8"?>
+<p:sld xmlns:a="http://schemas.openxmlformats.org/drawingml/2006/main" xmlns:r="http://schemas.openxmlformats.org/officeDocument/2006/relationships" xmlns:p="http://schemas.openxmlformats.org/presentationml/2006/main">
+  <p:cSld>
+    <p:spTree>
+      <p:nvGrpSpPr>
         <p:cNvPr id="1" name=""/>
         <p:cNvGrpSpPr/>
         <p:nvPr/>
@@ -7894,7 +9082,7 @@
 </p:sld>
 </file>
 
-<file path=ppt/slides/slide8.xml><?xml version="1.0" encoding="utf-8"?>
+<file path=ppt/slides/slide9.xml><?xml version="1.0" encoding="utf-8"?>
 <p:sld xmlns:a="http://schemas.openxmlformats.org/drawingml/2006/main" xmlns:r="http://schemas.openxmlformats.org/officeDocument/2006/relationships" xmlns:p="http://schemas.openxmlformats.org/presentationml/2006/main">
   <p:cSld>
     <p:spTree>
@@ -7948,7 +9136,7 @@
             <a:pPr algn="l"/>
             <a:r>
               <a:rPr lang="en-GB" sz="2800" dirty="0"/>
-              <a:t>3. Selected method 02: YYYY</a:t>
+              <a:t>3. Selected method (Deep 02): Grounded-SAM</a:t>
             </a:r>
           </a:p>
         </p:txBody>
@@ -8011,94 +9199,54 @@
           </a:p>
         </p:txBody>
       </p:sp>
-    </p:spTree>
-    <p:extLst>
-      <p:ext uri="{BB962C8B-B14F-4D97-AF65-F5344CB8AC3E}">
-        <p14:creationId xmlns:p14="http://schemas.microsoft.com/office/powerpoint/2010/main" val="3050205436"/>
-      </p:ext>
-    </p:extLst>
-  </p:cSld>
-  <p:clrMapOvr>
-    <a:masterClrMapping/>
-  </p:clrMapOvr>
-</p:sld>
-</file>
-
-<file path=ppt/slides/slide9.xml><?xml version="1.0" encoding="utf-8"?>
-<p:sld xmlns:a="http://schemas.openxmlformats.org/drawingml/2006/main" xmlns:r="http://schemas.openxmlformats.org/officeDocument/2006/relationships" xmlns:p="http://schemas.openxmlformats.org/presentationml/2006/main">
-  <p:cSld>
-    <p:spTree>
-      <p:nvGrpSpPr>
-        <p:cNvPr id="1" name="">
-          <a:extLst>
-            <a:ext uri="{FF2B5EF4-FFF2-40B4-BE49-F238E27FC236}">
-              <a16:creationId xmlns:a16="http://schemas.microsoft.com/office/drawing/2014/main" id="{F4CD17D0-6AE0-335D-DCCB-779C22440197}"/>
-            </a:ext>
-          </a:extLst>
-        </p:cNvPr>
-        <p:cNvGrpSpPr/>
-        <p:nvPr/>
-      </p:nvGrpSpPr>
-      <p:grpSpPr>
-        <a:xfrm>
-          <a:off x="0" y="0"/>
-          <a:ext cx="0" cy="0"/>
-          <a:chOff x="0" y="0"/>
-          <a:chExt cx="0" cy="0"/>
-        </a:xfrm>
-      </p:grpSpPr>
+      <p:pic>
+        <p:nvPicPr>
+          <p:cNvPr id="7" name="Imagen 6">
+            <a:extLst>
+              <a:ext uri="{FF2B5EF4-FFF2-40B4-BE49-F238E27FC236}">
+                <a16:creationId xmlns:a16="http://schemas.microsoft.com/office/drawing/2014/main" id="{5DA4DB5B-7178-9422-2D2D-DE06F57C981C}"/>
+              </a:ext>
+            </a:extLst>
+          </p:cNvPr>
+          <p:cNvPicPr>
+            <a:picLocks noChangeAspect="1"/>
+          </p:cNvPicPr>
+          <p:nvPr/>
+        </p:nvPicPr>
+        <p:blipFill>
+          <a:blip r:embed="rId3"/>
+          <a:stretch>
+            <a:fillRect/>
+          </a:stretch>
+        </p:blipFill>
+        <p:spPr>
+          <a:xfrm>
+            <a:off x="3713018" y="2134759"/>
+            <a:ext cx="4965700" cy="4393185"/>
+          </a:xfrm>
+          <a:prstGeom prst="rect">
+            <a:avLst/>
+          </a:prstGeom>
+        </p:spPr>
+      </p:pic>
       <p:sp>
         <p:nvSpPr>
-          <p:cNvPr id="2" name="Title 1">
+          <p:cNvPr id="3" name="Rectangle 9">
             <a:extLst>
               <a:ext uri="{FF2B5EF4-FFF2-40B4-BE49-F238E27FC236}">
-                <a16:creationId xmlns:a16="http://schemas.microsoft.com/office/drawing/2014/main" id="{ABE9FD54-E3E9-1AA0-9DD9-0517F99B7216}"/>
+                <a16:creationId xmlns:a16="http://schemas.microsoft.com/office/drawing/2014/main" id="{9432D02F-CFEC-0CCD-2E78-CC886AAA6DD2}"/>
               </a:ext>
             </a:extLst>
           </p:cNvPr>
           <p:cNvSpPr>
-            <a:spLocks noGrp="1"/>
+            <a:spLocks noChangeArrowheads="1"/>
           </p:cNvSpPr>
-          <p:nvPr>
-            <p:ph type="title"/>
-          </p:nvPr>
-        </p:nvSpPr>
-        <p:spPr>
-          <a:xfrm>
-            <a:off x="457200" y="274638"/>
-            <a:ext cx="7302500" cy="788278"/>
-          </a:xfrm>
-        </p:spPr>
-        <p:txBody>
-          <a:bodyPr>
-            <a:normAutofit/>
-          </a:bodyPr>
-          <a:lstStyle/>
-          <a:p>
-            <a:pPr algn="l"/>
-            <a:r>
-              <a:rPr lang="en-GB" sz="2800" dirty="0"/>
-              <a:t>3. Selected method 03: ZZZZ</a:t>
-            </a:r>
-          </a:p>
-        </p:txBody>
-      </p:sp>
-      <p:sp>
-        <p:nvSpPr>
-          <p:cNvPr id="30" name="Rectangle 7">
-            <a:extLst>
-              <a:ext uri="{FF2B5EF4-FFF2-40B4-BE49-F238E27FC236}">
-                <a16:creationId xmlns:a16="http://schemas.microsoft.com/office/drawing/2014/main" id="{36C84E96-7653-5D12-E6C6-A76E4A341C6C}"/>
-              </a:ext>
-            </a:extLst>
-          </p:cNvPr>
-          <p:cNvSpPr/>
           <p:nvPr/>
         </p:nvSpPr>
-        <p:spPr>
+        <p:spPr bwMode="auto">
           <a:xfrm>
-            <a:off x="80137" y="66509"/>
-            <a:ext cx="6565636" cy="303085"/>
+            <a:off x="910871" y="1501092"/>
+            <a:ext cx="5734902" cy="1631216"/>
           </a:xfrm>
           <a:prstGeom prst="rect">
             <a:avLst/>
@@ -8107,36 +9255,369 @@
           <a:ln>
             <a:noFill/>
           </a:ln>
+          <a:effectLst/>
           <a:extLst>
             <a:ext uri="{909E8E84-426E-40DD-AFC4-6F175D3DCCD1}">
               <a14:hiddenFill xmlns:a14="http://schemas.microsoft.com/office/drawing/2010/main">
                 <a:solidFill>
-                  <a:srgbClr val="FFFFFF"/>
+                  <a:schemeClr val="accent1"/>
                 </a:solidFill>
               </a14:hiddenFill>
             </a:ext>
             <a:ext uri="{91240B29-F687-4F45-9708-019B960494DF}">
-              <a14:hiddenLine xmlns:a14="http://schemas.microsoft.com/office/drawing/2010/main" w="9525" cap="flat">
-                <a:solidFill>
-                  <a:srgbClr val="000000"/>
+              <a14:hiddenLine xmlns:a14="http://schemas.microsoft.com/office/drawing/2010/main" w="9525">
+                <a:solidFill>
+                  <a:schemeClr val="tx1"/>
                 </a:solidFill>
                 <a:miter lim="800000"/>
-                <a:headEnd type="none" w="med" len="med"/>
-                <a:tailEnd type="none" w="med" len="med"/>
+                <a:headEnd/>
+                <a:tailEnd/>
               </a14:hiddenLine>
+            </a:ext>
+            <a:ext uri="{AF507438-7753-43E0-B8FC-AC1667EBCBE1}">
+              <a14:hiddenEffects xmlns:a14="http://schemas.microsoft.com/office/drawing/2010/main">
+                <a:effectLst>
+                  <a:outerShdw dist="35921" dir="2700000" algn="ctr" rotWithShape="0">
+                    <a:schemeClr val="bg2"/>
+                  </a:outerShdw>
+                </a:effectLst>
+              </a14:hiddenEffects>
             </a:ext>
           </a:extLst>
         </p:spPr>
         <p:txBody>
-          <a:bodyPr lIns="0" tIns="0" rIns="0" bIns="0"/>
+          <a:bodyPr vert="horz" wrap="square" lIns="91440" tIns="45720" rIns="91440" bIns="45720" numCol="1" anchor="ctr" anchorCtr="0" compatLnSpc="1">
+            <a:prstTxWarp prst="textNoShape">
+              <a:avLst/>
+            </a:prstTxWarp>
+            <a:spAutoFit/>
+          </a:bodyPr>
           <a:lstStyle/>
           <a:p>
-            <a:endParaRPr lang="en-US" sz="800" b="1" dirty="0">
+            <a:pPr lvl="0" defTabSz="914400" eaLnBrk="0" fontAlgn="base" hangingPunct="0">
+              <a:spcBef>
+                <a:spcPct val="0"/>
+              </a:spcBef>
+              <a:spcAft>
+                <a:spcPct val="0"/>
+              </a:spcAft>
+              <a:buFontTx/>
+              <a:buChar char="•"/>
+            </a:pPr>
+            <a:r>
+              <a:rPr kumimoji="0" lang="es-ES" altLang="es-ES" sz="2000" b="0" i="0" u="none" strike="noStrike" cap="none" normalizeH="0" baseline="0" dirty="0">
+                <a:ln>
+                  <a:noFill/>
+                </a:ln>
+                <a:solidFill>
+                  <a:schemeClr val="tx1"/>
+                </a:solidFill>
+                <a:effectLst/>
+                <a:latin typeface="Arial" panose="020B0604020202020204" pitchFamily="34" charset="0"/>
+              </a:rPr>
+              <a:t> </a:t>
+            </a:r>
+            <a:r>
+              <a:rPr lang="es-ES" dirty="0"/>
+              <a:t>🔗</a:t>
+            </a:r>
+            <a:r>
+              <a:rPr lang="es-ES" altLang="es-ES" sz="2000" dirty="0" err="1">
+                <a:latin typeface="Arial" panose="020B0604020202020204" pitchFamily="34" charset="0"/>
+              </a:rPr>
+              <a:t>Detection</a:t>
+            </a:r>
+            <a:r>
+              <a:rPr lang="es-ES" altLang="es-ES" sz="2000" dirty="0">
+                <a:latin typeface="Arial" panose="020B0604020202020204" pitchFamily="34" charset="0"/>
+              </a:rPr>
+              <a:t> + </a:t>
+            </a:r>
+            <a:r>
+              <a:rPr lang="es-ES" altLang="es-ES" sz="2000" dirty="0" err="1">
+                <a:latin typeface="Arial" panose="020B0604020202020204" pitchFamily="34" charset="0"/>
+              </a:rPr>
+              <a:t>segmentation</a:t>
+            </a:r>
+            <a:r>
+              <a:rPr lang="es-ES" altLang="es-ES" sz="2000" dirty="0">
+                <a:latin typeface="Arial" panose="020B0604020202020204" pitchFamily="34" charset="0"/>
+              </a:rPr>
+              <a:t> pipeline (2-stage)</a:t>
+            </a:r>
+            <a:endParaRPr kumimoji="0" lang="es-ES" altLang="es-ES" sz="2000" b="0" i="0" u="none" strike="noStrike" cap="none" normalizeH="0" baseline="0" dirty="0">
+              <a:ln>
+                <a:noFill/>
+              </a:ln>
               <a:solidFill>
-                <a:srgbClr val="535353"/>
+                <a:schemeClr val="tx1"/>
               </a:solidFill>
-              <a:latin typeface="Geneva" charset="0"/>
-              <a:cs typeface="Geneva" charset="0"/>
+              <a:effectLst/>
+              <a:latin typeface="Arial" panose="020B0604020202020204" pitchFamily="34" charset="0"/>
+            </a:endParaRPr>
+          </a:p>
+          <a:p>
+            <a:pPr lvl="0" defTabSz="914400" eaLnBrk="0" fontAlgn="base" hangingPunct="0">
+              <a:spcBef>
+                <a:spcPct val="0"/>
+              </a:spcBef>
+              <a:spcAft>
+                <a:spcPct val="0"/>
+              </a:spcAft>
+              <a:buFontTx/>
+              <a:buChar char="•"/>
+            </a:pPr>
+            <a:r>
+              <a:rPr kumimoji="0" lang="es-ES" altLang="es-ES" sz="2000" b="0" i="0" u="none" strike="noStrike" cap="none" normalizeH="0" baseline="0" dirty="0">
+                <a:ln>
+                  <a:noFill/>
+                </a:ln>
+                <a:solidFill>
+                  <a:schemeClr val="tx1"/>
+                </a:solidFill>
+                <a:effectLst/>
+                <a:latin typeface="Arial" panose="020B0604020202020204" pitchFamily="34" charset="0"/>
+              </a:rPr>
+              <a:t> </a:t>
+            </a:r>
+            <a:r>
+              <a:rPr lang="es-ES" dirty="0"/>
+              <a:t>📝</a:t>
+            </a:r>
+            <a:r>
+              <a:rPr kumimoji="0" lang="es-ES" altLang="es-ES" sz="2000" b="0" i="0" u="none" strike="noStrike" cap="none" normalizeH="0" baseline="0" dirty="0">
+                <a:ln>
+                  <a:noFill/>
+                </a:ln>
+                <a:solidFill>
+                  <a:schemeClr val="tx1"/>
+                </a:solidFill>
+                <a:effectLst/>
+                <a:latin typeface="Arial" panose="020B0604020202020204" pitchFamily="34" charset="0"/>
+              </a:rPr>
+              <a:t>Open-</a:t>
+            </a:r>
+            <a:r>
+              <a:rPr kumimoji="0" lang="es-ES" altLang="es-ES" sz="2000" b="0" i="0" u="none" strike="noStrike" cap="none" normalizeH="0" baseline="0" dirty="0" err="1">
+                <a:ln>
+                  <a:noFill/>
+                </a:ln>
+                <a:solidFill>
+                  <a:schemeClr val="tx1"/>
+                </a:solidFill>
+                <a:effectLst/>
+                <a:latin typeface="Arial" panose="020B0604020202020204" pitchFamily="34" charset="0"/>
+              </a:rPr>
+              <a:t>vocabulary</a:t>
+            </a:r>
+            <a:endParaRPr lang="es-ES" altLang="es-ES" sz="2000" dirty="0">
+              <a:latin typeface="Arial" panose="020B0604020202020204" pitchFamily="34" charset="0"/>
+            </a:endParaRPr>
+          </a:p>
+          <a:p>
+            <a:pPr lvl="0" defTabSz="914400" eaLnBrk="0" fontAlgn="base" hangingPunct="0">
+              <a:spcBef>
+                <a:spcPct val="0"/>
+              </a:spcBef>
+              <a:spcAft>
+                <a:spcPct val="0"/>
+              </a:spcAft>
+              <a:buFontTx/>
+              <a:buChar char="•"/>
+            </a:pPr>
+            <a:r>
+              <a:rPr kumimoji="0" lang="es-ES" altLang="es-ES" sz="2000" b="0" i="0" u="none" strike="noStrike" cap="none" normalizeH="0" baseline="0" dirty="0">
+                <a:ln>
+                  <a:noFill/>
+                </a:ln>
+                <a:solidFill>
+                  <a:schemeClr val="tx1"/>
+                </a:solidFill>
+                <a:effectLst/>
+                <a:latin typeface="Arial" panose="020B0604020202020204" pitchFamily="34" charset="0"/>
+              </a:rPr>
+              <a:t> </a:t>
+            </a:r>
+            <a:r>
+              <a:rPr lang="es-ES" dirty="0"/>
+              <a:t>📦</a:t>
+            </a:r>
+            <a:r>
+              <a:rPr kumimoji="0" lang="es-ES" altLang="es-ES" sz="2000" b="0" i="0" u="none" strike="noStrike" cap="none" normalizeH="0" baseline="0" dirty="0" err="1">
+                <a:ln>
+                  <a:noFill/>
+                </a:ln>
+                <a:solidFill>
+                  <a:schemeClr val="tx1"/>
+                </a:solidFill>
+                <a:effectLst/>
+                <a:latin typeface="Arial" panose="020B0604020202020204" pitchFamily="34" charset="0"/>
+              </a:rPr>
+              <a:t>Object</a:t>
+            </a:r>
+            <a:r>
+              <a:rPr kumimoji="0" lang="es-ES" altLang="es-ES" sz="2000" b="0" i="0" u="none" strike="noStrike" cap="none" normalizeH="0" baseline="0" dirty="0">
+                <a:ln>
+                  <a:noFill/>
+                </a:ln>
+                <a:solidFill>
+                  <a:schemeClr val="tx1"/>
+                </a:solidFill>
+                <a:effectLst/>
+                <a:latin typeface="Arial" panose="020B0604020202020204" pitchFamily="34" charset="0"/>
+              </a:rPr>
+              <a:t> </a:t>
+            </a:r>
+            <a:r>
+              <a:rPr kumimoji="0" lang="es-ES" altLang="es-ES" sz="2000" b="0" i="0" u="none" strike="noStrike" cap="none" normalizeH="0" baseline="0" dirty="0" err="1">
+                <a:ln>
+                  <a:noFill/>
+                </a:ln>
+                <a:solidFill>
+                  <a:schemeClr val="tx1"/>
+                </a:solidFill>
+                <a:effectLst/>
+                <a:latin typeface="Arial" panose="020B0604020202020204" pitchFamily="34" charset="0"/>
+              </a:rPr>
+              <a:t>detection</a:t>
+            </a:r>
+            <a:endParaRPr kumimoji="0" lang="es-ES" altLang="es-ES" sz="2000" b="0" i="0" u="none" strike="noStrike" cap="none" normalizeH="0" baseline="0" dirty="0">
+              <a:ln>
+                <a:noFill/>
+              </a:ln>
+              <a:solidFill>
+                <a:schemeClr val="tx1"/>
+              </a:solidFill>
+              <a:effectLst/>
+              <a:latin typeface="Arial" panose="020B0604020202020204" pitchFamily="34" charset="0"/>
+            </a:endParaRPr>
+          </a:p>
+          <a:p>
+            <a:pPr lvl="0" defTabSz="914400" eaLnBrk="0" fontAlgn="base" hangingPunct="0">
+              <a:spcBef>
+                <a:spcPct val="0"/>
+              </a:spcBef>
+              <a:spcAft>
+                <a:spcPct val="0"/>
+              </a:spcAft>
+              <a:buFontTx/>
+              <a:buChar char="•"/>
+            </a:pPr>
+            <a:r>
+              <a:rPr kumimoji="0" lang="es-ES" altLang="es-ES" sz="2000" b="0" i="0" u="none" strike="noStrike" cap="none" normalizeH="0" baseline="0" dirty="0">
+                <a:ln>
+                  <a:noFill/>
+                </a:ln>
+                <a:solidFill>
+                  <a:schemeClr val="tx1"/>
+                </a:solidFill>
+                <a:effectLst/>
+                <a:latin typeface="Arial" panose="020B0604020202020204" pitchFamily="34" charset="0"/>
+              </a:rPr>
+              <a:t> </a:t>
+            </a:r>
+            <a:r>
+              <a:rPr lang="es-ES" dirty="0"/>
+              <a:t>🎯</a:t>
+            </a:r>
+            <a:r>
+              <a:rPr kumimoji="0" lang="es-ES" altLang="es-ES" sz="2000" b="0" i="0" u="none" strike="noStrike" cap="none" normalizeH="0" baseline="0" dirty="0">
+                <a:ln>
+                  <a:noFill/>
+                </a:ln>
+                <a:solidFill>
+                  <a:schemeClr val="tx1"/>
+                </a:solidFill>
+                <a:effectLst/>
+                <a:latin typeface="Arial" panose="020B0604020202020204" pitchFamily="34" charset="0"/>
+              </a:rPr>
+              <a:t>Precise </a:t>
+            </a:r>
+            <a:r>
+              <a:rPr kumimoji="0" lang="es-ES" altLang="es-ES" sz="2000" b="0" i="0" u="none" strike="noStrike" cap="none" normalizeH="0" baseline="0" dirty="0" err="1">
+                <a:ln>
+                  <a:noFill/>
+                </a:ln>
+                <a:solidFill>
+                  <a:schemeClr val="tx1"/>
+                </a:solidFill>
+                <a:effectLst/>
+                <a:latin typeface="Arial" panose="020B0604020202020204" pitchFamily="34" charset="0"/>
+              </a:rPr>
+              <a:t>segmentation</a:t>
+            </a:r>
+            <a:r>
+              <a:rPr kumimoji="0" lang="es-ES" altLang="es-ES" sz="2000" b="0" i="0" u="none" strike="noStrike" cap="none" normalizeH="0" baseline="0" dirty="0">
+                <a:ln>
+                  <a:noFill/>
+                </a:ln>
+                <a:solidFill>
+                  <a:schemeClr val="tx1"/>
+                </a:solidFill>
+                <a:effectLst/>
+                <a:latin typeface="Arial" panose="020B0604020202020204" pitchFamily="34" charset="0"/>
+              </a:rPr>
+              <a:t> </a:t>
+            </a:r>
+            <a:r>
+              <a:rPr kumimoji="0" lang="es-ES" altLang="es-ES" sz="2000" b="0" i="0" u="none" strike="noStrike" cap="none" normalizeH="0" baseline="0" dirty="0" err="1">
+                <a:ln>
+                  <a:noFill/>
+                </a:ln>
+                <a:solidFill>
+                  <a:schemeClr val="tx1"/>
+                </a:solidFill>
+                <a:effectLst/>
+                <a:latin typeface="Arial" panose="020B0604020202020204" pitchFamily="34" charset="0"/>
+              </a:rPr>
+              <a:t>masks</a:t>
+            </a:r>
+            <a:endParaRPr lang="es-ES" altLang="es-ES" sz="2000" dirty="0">
+              <a:latin typeface="Arial" panose="020B0604020202020204" pitchFamily="34" charset="0"/>
+            </a:endParaRPr>
+          </a:p>
+          <a:p>
+            <a:pPr lvl="0" defTabSz="914400" eaLnBrk="0" fontAlgn="base" hangingPunct="0">
+              <a:spcBef>
+                <a:spcPct val="0"/>
+              </a:spcBef>
+              <a:spcAft>
+                <a:spcPct val="0"/>
+              </a:spcAft>
+              <a:buFontTx/>
+              <a:buChar char="•"/>
+            </a:pPr>
+            <a:r>
+              <a:rPr lang="es-ES" altLang="es-ES" sz="2000" dirty="0">
+                <a:latin typeface="Arial" panose="020B0604020202020204" pitchFamily="34" charset="0"/>
+              </a:rPr>
+              <a:t> </a:t>
+            </a:r>
+            <a:r>
+              <a:rPr lang="es-ES" dirty="0"/>
+              <a:t>🚫</a:t>
+            </a:r>
+            <a:r>
+              <a:rPr lang="es-ES" altLang="es-ES" sz="2000" dirty="0">
+                <a:latin typeface="Arial" panose="020B0604020202020204" pitchFamily="34" charset="0"/>
+              </a:rPr>
+              <a:t>Zero-</a:t>
+            </a:r>
+            <a:r>
+              <a:rPr lang="es-ES" altLang="es-ES" sz="2000" dirty="0" err="1">
+                <a:latin typeface="Arial" panose="020B0604020202020204" pitchFamily="34" charset="0"/>
+              </a:rPr>
+              <a:t>shot</a:t>
+            </a:r>
+            <a:endParaRPr kumimoji="0" lang="es-ES" altLang="es-ES" sz="2000" b="0" i="0" u="none" strike="noStrike" cap="none" normalizeH="0" baseline="0" dirty="0">
+              <a:ln>
+                <a:noFill/>
+              </a:ln>
+              <a:solidFill>
+                <a:schemeClr val="tx1"/>
+              </a:solidFill>
+              <a:effectLst/>
+              <a:latin typeface="Arial" panose="020B0604020202020204" pitchFamily="34" charset="0"/>
             </a:endParaRPr>
           </a:p>
         </p:txBody>
@@ -8144,7 +9625,7 @@
     </p:spTree>
     <p:extLst>
       <p:ext uri="{BB962C8B-B14F-4D97-AF65-F5344CB8AC3E}">
-        <p14:creationId xmlns:p14="http://schemas.microsoft.com/office/powerpoint/2010/main" val="2985104822"/>
+        <p14:creationId xmlns:p14="http://schemas.microsoft.com/office/powerpoint/2010/main" val="3050205436"/>
       </p:ext>
     </p:extLst>
   </p:cSld>

</xml_diff>

<commit_message>
Dataset images and performance metrics added
</commit_message>
<xml_diff>
--- a/docs/GIDIA_VA_Course_Project_Presentations.pptx
+++ b/docs/GIDIA_VA_Course_Project_Presentations.pptx
@@ -4229,6 +4229,294 @@
           </a:prstGeom>
         </p:spPr>
       </p:pic>
+      <p:pic>
+        <p:nvPicPr>
+          <p:cNvPr id="5" name="Imagen 4">
+            <a:extLst>
+              <a:ext uri="{FF2B5EF4-FFF2-40B4-BE49-F238E27FC236}">
+                <a16:creationId xmlns:a16="http://schemas.microsoft.com/office/drawing/2014/main" id="{A260E61C-CF0C-CBB4-6FFE-05A177CE5043}"/>
+              </a:ext>
+            </a:extLst>
+          </p:cNvPr>
+          <p:cNvPicPr>
+            <a:picLocks noChangeAspect="1"/>
+          </p:cNvPicPr>
+          <p:nvPr/>
+        </p:nvPicPr>
+        <p:blipFill>
+          <a:blip r:embed="rId4">
+            <a:alphaModFix amt="25000"/>
+          </a:blip>
+          <a:stretch>
+            <a:fillRect/>
+          </a:stretch>
+        </p:blipFill>
+        <p:spPr>
+          <a:xfrm>
+            <a:off x="1830070" y="2214693"/>
+            <a:ext cx="5144218" cy="2682303"/>
+          </a:xfrm>
+          <a:prstGeom prst="rect">
+            <a:avLst/>
+          </a:prstGeom>
+        </p:spPr>
+      </p:pic>
+      <p:pic>
+        <p:nvPicPr>
+          <p:cNvPr id="7" name="Imagen 6">
+            <a:extLst>
+              <a:ext uri="{FF2B5EF4-FFF2-40B4-BE49-F238E27FC236}">
+                <a16:creationId xmlns:a16="http://schemas.microsoft.com/office/drawing/2014/main" id="{0FAAF5DB-34BF-083D-22DF-62A069380D99}"/>
+              </a:ext>
+            </a:extLst>
+          </p:cNvPr>
+          <p:cNvPicPr>
+            <a:picLocks noChangeAspect="1"/>
+          </p:cNvPicPr>
+          <p:nvPr/>
+        </p:nvPicPr>
+        <p:blipFill>
+          <a:blip r:embed="rId5">
+            <a:alphaModFix amt="25000"/>
+          </a:blip>
+          <a:stretch>
+            <a:fillRect/>
+          </a:stretch>
+        </p:blipFill>
+        <p:spPr>
+          <a:xfrm>
+            <a:off x="2211552" y="-1273662"/>
+            <a:ext cx="3505689" cy="3496163"/>
+          </a:xfrm>
+          <a:prstGeom prst="rect">
+            <a:avLst/>
+          </a:prstGeom>
+        </p:spPr>
+      </p:pic>
+      <p:pic>
+        <p:nvPicPr>
+          <p:cNvPr id="9" name="Imagen 8">
+            <a:extLst>
+              <a:ext uri="{FF2B5EF4-FFF2-40B4-BE49-F238E27FC236}">
+                <a16:creationId xmlns:a16="http://schemas.microsoft.com/office/drawing/2014/main" id="{855580D9-C421-EBC4-5246-EC8668D68033}"/>
+              </a:ext>
+            </a:extLst>
+          </p:cNvPr>
+          <p:cNvPicPr>
+            <a:picLocks noChangeAspect="1"/>
+          </p:cNvPicPr>
+          <p:nvPr/>
+        </p:nvPicPr>
+        <p:blipFill>
+          <a:blip r:embed="rId6">
+            <a:alphaModFix amt="25000"/>
+          </a:blip>
+          <a:stretch>
+            <a:fillRect/>
+          </a:stretch>
+        </p:blipFill>
+        <p:spPr>
+          <a:xfrm>
+            <a:off x="6974288" y="2214693"/>
+            <a:ext cx="2256189" cy="2682303"/>
+          </a:xfrm>
+          <a:prstGeom prst="rect">
+            <a:avLst/>
+          </a:prstGeom>
+        </p:spPr>
+      </p:pic>
+      <p:pic>
+        <p:nvPicPr>
+          <p:cNvPr id="11" name="Imagen 10">
+            <a:extLst>
+              <a:ext uri="{FF2B5EF4-FFF2-40B4-BE49-F238E27FC236}">
+                <a16:creationId xmlns:a16="http://schemas.microsoft.com/office/drawing/2014/main" id="{82486E68-9CF4-504D-368A-620B23577FCE}"/>
+              </a:ext>
+            </a:extLst>
+          </p:cNvPr>
+          <p:cNvPicPr>
+            <a:picLocks noChangeAspect="1"/>
+          </p:cNvPicPr>
+          <p:nvPr/>
+        </p:nvPicPr>
+        <p:blipFill>
+          <a:blip r:embed="rId7">
+            <a:alphaModFix amt="25000"/>
+          </a:blip>
+          <a:stretch>
+            <a:fillRect/>
+          </a:stretch>
+        </p:blipFill>
+        <p:spPr>
+          <a:xfrm>
+            <a:off x="41840" y="2209932"/>
+            <a:ext cx="1811024" cy="2687065"/>
+          </a:xfrm>
+          <a:prstGeom prst="rect">
+            <a:avLst/>
+          </a:prstGeom>
+        </p:spPr>
+      </p:pic>
+      <p:pic>
+        <p:nvPicPr>
+          <p:cNvPr id="13" name="Imagen 12">
+            <a:extLst>
+              <a:ext uri="{FF2B5EF4-FFF2-40B4-BE49-F238E27FC236}">
+                <a16:creationId xmlns:a16="http://schemas.microsoft.com/office/drawing/2014/main" id="{2D638B83-C0BC-277A-2A30-FC389C17D3B2}"/>
+              </a:ext>
+            </a:extLst>
+          </p:cNvPr>
+          <p:cNvPicPr>
+            <a:picLocks noChangeAspect="1"/>
+          </p:cNvPicPr>
+          <p:nvPr/>
+        </p:nvPicPr>
+        <p:blipFill>
+          <a:blip r:embed="rId8">
+            <a:alphaModFix amt="25000"/>
+          </a:blip>
+          <a:stretch>
+            <a:fillRect/>
+          </a:stretch>
+        </p:blipFill>
+        <p:spPr>
+          <a:xfrm>
+            <a:off x="2481544" y="4896997"/>
+            <a:ext cx="4677428" cy="3524742"/>
+          </a:xfrm>
+          <a:prstGeom prst="rect">
+            <a:avLst/>
+          </a:prstGeom>
+        </p:spPr>
+      </p:pic>
+      <p:pic>
+        <p:nvPicPr>
+          <p:cNvPr id="15" name="Imagen 14">
+            <a:extLst>
+              <a:ext uri="{FF2B5EF4-FFF2-40B4-BE49-F238E27FC236}">
+                <a16:creationId xmlns:a16="http://schemas.microsoft.com/office/drawing/2014/main" id="{3C26A960-DB73-47B8-43F0-D6BBE57C2BE7}"/>
+              </a:ext>
+            </a:extLst>
+          </p:cNvPr>
+          <p:cNvPicPr>
+            <a:picLocks noChangeAspect="1"/>
+          </p:cNvPicPr>
+          <p:nvPr/>
+        </p:nvPicPr>
+        <p:blipFill>
+          <a:blip r:embed="rId9">
+            <a:alphaModFix amt="25000"/>
+          </a:blip>
+          <a:stretch>
+            <a:fillRect/>
+          </a:stretch>
+        </p:blipFill>
+        <p:spPr>
+          <a:xfrm>
+            <a:off x="5717241" y="-1254609"/>
+            <a:ext cx="4505954" cy="3464541"/>
+          </a:xfrm>
+          <a:prstGeom prst="rect">
+            <a:avLst/>
+          </a:prstGeom>
+        </p:spPr>
+      </p:pic>
+      <p:pic>
+        <p:nvPicPr>
+          <p:cNvPr id="17" name="Imagen 16">
+            <a:extLst>
+              <a:ext uri="{FF2B5EF4-FFF2-40B4-BE49-F238E27FC236}">
+                <a16:creationId xmlns:a16="http://schemas.microsoft.com/office/drawing/2014/main" id="{19B3B48B-9993-B496-C19C-444175ABBD00}"/>
+              </a:ext>
+            </a:extLst>
+          </p:cNvPr>
+          <p:cNvPicPr>
+            <a:picLocks noChangeAspect="1"/>
+          </p:cNvPicPr>
+          <p:nvPr/>
+        </p:nvPicPr>
+        <p:blipFill>
+          <a:blip r:embed="rId10">
+            <a:alphaModFix amt="25000"/>
+          </a:blip>
+          <a:stretch>
+            <a:fillRect/>
+          </a:stretch>
+        </p:blipFill>
+        <p:spPr>
+          <a:xfrm>
+            <a:off x="-55714" y="-1283188"/>
+            <a:ext cx="2267266" cy="3505689"/>
+          </a:xfrm>
+          <a:prstGeom prst="rect">
+            <a:avLst/>
+          </a:prstGeom>
+        </p:spPr>
+      </p:pic>
+      <p:pic>
+        <p:nvPicPr>
+          <p:cNvPr id="19" name="Imagen 18">
+            <a:extLst>
+              <a:ext uri="{FF2B5EF4-FFF2-40B4-BE49-F238E27FC236}">
+                <a16:creationId xmlns:a16="http://schemas.microsoft.com/office/drawing/2014/main" id="{30A69AC1-C53D-33B4-105A-AD149AD6C994}"/>
+              </a:ext>
+            </a:extLst>
+          </p:cNvPr>
+          <p:cNvPicPr>
+            <a:picLocks noChangeAspect="1"/>
+          </p:cNvPicPr>
+          <p:nvPr/>
+        </p:nvPicPr>
+        <p:blipFill>
+          <a:blip r:embed="rId11">
+            <a:alphaModFix amt="25000"/>
+          </a:blip>
+          <a:stretch>
+            <a:fillRect/>
+          </a:stretch>
+        </p:blipFill>
+        <p:spPr>
+          <a:xfrm>
+            <a:off x="1270" y="4896997"/>
+            <a:ext cx="2481545" cy="2586646"/>
+          </a:xfrm>
+          <a:prstGeom prst="rect">
+            <a:avLst/>
+          </a:prstGeom>
+        </p:spPr>
+      </p:pic>
+      <p:pic>
+        <p:nvPicPr>
+          <p:cNvPr id="21" name="Imagen 20">
+            <a:extLst>
+              <a:ext uri="{FF2B5EF4-FFF2-40B4-BE49-F238E27FC236}">
+                <a16:creationId xmlns:a16="http://schemas.microsoft.com/office/drawing/2014/main" id="{FA96640A-2C49-3A0D-2C3B-3C04FF71F173}"/>
+              </a:ext>
+            </a:extLst>
+          </p:cNvPr>
+          <p:cNvPicPr>
+            <a:picLocks noChangeAspect="1"/>
+          </p:cNvPicPr>
+          <p:nvPr/>
+        </p:nvPicPr>
+        <p:blipFill>
+          <a:blip r:embed="rId12">
+            <a:alphaModFix amt="25000"/>
+          </a:blip>
+          <a:stretch>
+            <a:fillRect/>
+          </a:stretch>
+        </p:blipFill>
+        <p:spPr>
+          <a:xfrm>
+            <a:off x="7155717" y="4896997"/>
+            <a:ext cx="3067478" cy="2267266"/>
+          </a:xfrm>
+          <a:prstGeom prst="rect">
+            <a:avLst/>
+          </a:prstGeom>
+        </p:spPr>
+      </p:pic>
     </p:spTree>
     <p:extLst>
       <p:ext uri="{BB962C8B-B14F-4D97-AF65-F5344CB8AC3E}">
@@ -4359,6 +4647,680 @@
           </a:p>
         </p:txBody>
       </p:sp>
+      <p:sp>
+        <p:nvSpPr>
+          <p:cNvPr id="3" name="Content Placeholder 2">
+            <a:extLst>
+              <a:ext uri="{FF2B5EF4-FFF2-40B4-BE49-F238E27FC236}">
+                <a16:creationId xmlns:a16="http://schemas.microsoft.com/office/drawing/2014/main" id="{1AB30589-8C05-AEC0-1C75-C4A06851FC0A}"/>
+              </a:ext>
+            </a:extLst>
+          </p:cNvPr>
+          <p:cNvSpPr txBox="1">
+            <a:spLocks/>
+          </p:cNvSpPr>
+          <p:nvPr/>
+        </p:nvSpPr>
+        <p:spPr>
+          <a:xfrm>
+            <a:off x="486698" y="1416337"/>
+            <a:ext cx="3920249" cy="2012664"/>
+          </a:xfrm>
+          <a:prstGeom prst="rect">
+            <a:avLst/>
+          </a:prstGeom>
+        </p:spPr>
+        <p:txBody>
+          <a:bodyPr vert="horz" lIns="91440" tIns="45720" rIns="91440" bIns="45720" rtlCol="0">
+            <a:noAutofit/>
+          </a:bodyPr>
+          <a:lstStyle>
+            <a:defPPr>
+              <a:defRPr lang="en-US"/>
+            </a:defPPr>
+            <a:lvl1pPr marL="0" algn="l" defTabSz="457200" rtl="0" eaLnBrk="1" latinLnBrk="0" hangingPunct="1">
+              <a:defRPr sz="1800" kern="1200">
+                <a:solidFill>
+                  <a:schemeClr val="tx1"/>
+                </a:solidFill>
+                <a:latin typeface="+mn-lt"/>
+                <a:ea typeface="+mn-ea"/>
+                <a:cs typeface="+mn-cs"/>
+              </a:defRPr>
+            </a:lvl1pPr>
+            <a:lvl2pPr marL="457200" algn="l" defTabSz="457200" rtl="0" eaLnBrk="1" latinLnBrk="0" hangingPunct="1">
+              <a:defRPr sz="1800" kern="1200">
+                <a:solidFill>
+                  <a:schemeClr val="tx1"/>
+                </a:solidFill>
+                <a:latin typeface="+mn-lt"/>
+                <a:ea typeface="+mn-ea"/>
+                <a:cs typeface="+mn-cs"/>
+              </a:defRPr>
+            </a:lvl2pPr>
+            <a:lvl3pPr marL="914400" algn="l" defTabSz="457200" rtl="0" eaLnBrk="1" latinLnBrk="0" hangingPunct="1">
+              <a:defRPr sz="1800" kern="1200">
+                <a:solidFill>
+                  <a:schemeClr val="tx1"/>
+                </a:solidFill>
+                <a:latin typeface="+mn-lt"/>
+                <a:ea typeface="+mn-ea"/>
+                <a:cs typeface="+mn-cs"/>
+              </a:defRPr>
+            </a:lvl3pPr>
+            <a:lvl4pPr marL="1371600" algn="l" defTabSz="457200" rtl="0" eaLnBrk="1" latinLnBrk="0" hangingPunct="1">
+              <a:defRPr sz="1800" kern="1200">
+                <a:solidFill>
+                  <a:schemeClr val="tx1"/>
+                </a:solidFill>
+                <a:latin typeface="+mn-lt"/>
+                <a:ea typeface="+mn-ea"/>
+                <a:cs typeface="+mn-cs"/>
+              </a:defRPr>
+            </a:lvl4pPr>
+            <a:lvl5pPr marL="1828800" algn="l" defTabSz="457200" rtl="0" eaLnBrk="1" latinLnBrk="0" hangingPunct="1">
+              <a:defRPr sz="1800" kern="1200">
+                <a:solidFill>
+                  <a:schemeClr val="tx1"/>
+                </a:solidFill>
+                <a:latin typeface="+mn-lt"/>
+                <a:ea typeface="+mn-ea"/>
+                <a:cs typeface="+mn-cs"/>
+              </a:defRPr>
+            </a:lvl5pPr>
+            <a:lvl6pPr marL="2286000" algn="l" defTabSz="457200" rtl="0" eaLnBrk="1" latinLnBrk="0" hangingPunct="1">
+              <a:defRPr sz="1800" kern="1200">
+                <a:solidFill>
+                  <a:schemeClr val="tx1"/>
+                </a:solidFill>
+                <a:latin typeface="+mn-lt"/>
+                <a:ea typeface="+mn-ea"/>
+                <a:cs typeface="+mn-cs"/>
+              </a:defRPr>
+            </a:lvl6pPr>
+            <a:lvl7pPr marL="2743200" algn="l" defTabSz="457200" rtl="0" eaLnBrk="1" latinLnBrk="0" hangingPunct="1">
+              <a:defRPr sz="1800" kern="1200">
+                <a:solidFill>
+                  <a:schemeClr val="tx1"/>
+                </a:solidFill>
+                <a:latin typeface="+mn-lt"/>
+                <a:ea typeface="+mn-ea"/>
+                <a:cs typeface="+mn-cs"/>
+              </a:defRPr>
+            </a:lvl7pPr>
+            <a:lvl8pPr marL="3200400" algn="l" defTabSz="457200" rtl="0" eaLnBrk="1" latinLnBrk="0" hangingPunct="1">
+              <a:defRPr sz="1800" kern="1200">
+                <a:solidFill>
+                  <a:schemeClr val="tx1"/>
+                </a:solidFill>
+                <a:latin typeface="+mn-lt"/>
+                <a:ea typeface="+mn-ea"/>
+                <a:cs typeface="+mn-cs"/>
+              </a:defRPr>
+            </a:lvl8pPr>
+            <a:lvl9pPr marL="3657600" algn="l" defTabSz="457200" rtl="0" eaLnBrk="1" latinLnBrk="0" hangingPunct="1">
+              <a:defRPr sz="1800" kern="1200">
+                <a:solidFill>
+                  <a:schemeClr val="tx1"/>
+                </a:solidFill>
+                <a:latin typeface="+mn-lt"/>
+                <a:ea typeface="+mn-ea"/>
+                <a:cs typeface="+mn-cs"/>
+              </a:defRPr>
+            </a:lvl9pPr>
+          </a:lstStyle>
+          <a:p>
+            <a:pPr>
+              <a:buNone/>
+            </a:pPr>
+            <a:r>
+              <a:rPr lang="es-ES" sz="2000" dirty="0"/>
+              <a:t>🔹 </a:t>
+            </a:r>
+            <a:r>
+              <a:rPr lang="es-ES" sz="2000" b="1" dirty="0" err="1"/>
+              <a:t>Detection</a:t>
+            </a:r>
+            <a:r>
+              <a:rPr lang="es-ES" sz="2000" b="1" dirty="0"/>
+              <a:t> &amp; </a:t>
+            </a:r>
+            <a:r>
+              <a:rPr lang="es-ES" sz="2000" b="1" dirty="0" err="1"/>
+              <a:t>Segmentation</a:t>
+            </a:r>
+            <a:br>
+              <a:rPr lang="es-ES" sz="2000" dirty="0"/>
+            </a:br>
+            <a:r>
+              <a:rPr lang="es-ES" sz="2000" dirty="0"/>
+              <a:t>- </a:t>
+            </a:r>
+            <a:r>
+              <a:rPr lang="es-ES" dirty="0"/>
+              <a:t>📦</a:t>
+            </a:r>
+            <a:r>
+              <a:rPr lang="es-ES" sz="2000" dirty="0"/>
+              <a:t> </a:t>
+            </a:r>
+            <a:r>
+              <a:rPr lang="es-ES" sz="2000" dirty="0" err="1"/>
+              <a:t>Precision</a:t>
+            </a:r>
+            <a:r>
+              <a:rPr lang="es-ES" sz="2000" dirty="0"/>
+              <a:t> / </a:t>
+            </a:r>
+            <a:r>
+              <a:rPr lang="es-ES" sz="2000" dirty="0" err="1"/>
+              <a:t>Recall</a:t>
+            </a:r>
+            <a:r>
+              <a:rPr lang="es-ES" sz="2000" dirty="0"/>
+              <a:t> / F1-Score</a:t>
+            </a:r>
+          </a:p>
+          <a:p>
+            <a:r>
+              <a:rPr lang="es-ES" sz="2000" dirty="0"/>
+              <a:t>- </a:t>
+            </a:r>
+            <a:r>
+              <a:rPr lang="es-ES" dirty="0"/>
+              <a:t>🎯</a:t>
+            </a:r>
+            <a:r>
+              <a:rPr lang="es-ES" sz="2000" dirty="0"/>
+              <a:t> </a:t>
+            </a:r>
+            <a:r>
+              <a:rPr lang="es-ES" sz="2000" dirty="0" err="1"/>
+              <a:t>IoU</a:t>
+            </a:r>
+            <a:r>
+              <a:rPr lang="es-ES" sz="2000" dirty="0"/>
+              <a:t> (</a:t>
+            </a:r>
+            <a:r>
+              <a:rPr lang="es-ES" sz="2000" dirty="0" err="1"/>
+              <a:t>overlap</a:t>
+            </a:r>
+            <a:r>
+              <a:rPr lang="es-ES" sz="2000" dirty="0"/>
+              <a:t> </a:t>
+            </a:r>
+            <a:r>
+              <a:rPr lang="es-ES" sz="2000" dirty="0" err="1"/>
+              <a:t>quality</a:t>
+            </a:r>
+            <a:r>
+              <a:rPr lang="es-ES" sz="2000" dirty="0"/>
+              <a:t>)</a:t>
+            </a:r>
+          </a:p>
+          <a:p>
+            <a:r>
+              <a:rPr lang="es-ES" sz="2000" dirty="0"/>
+              <a:t>- </a:t>
+            </a:r>
+            <a:r>
+              <a:rPr lang="es-ES" dirty="0"/>
+              <a:t>📊</a:t>
+            </a:r>
+            <a:r>
+              <a:rPr lang="es-ES" sz="2000" dirty="0"/>
+              <a:t> AP / </a:t>
+            </a:r>
+            <a:r>
+              <a:rPr lang="es-ES" sz="2000" dirty="0" err="1"/>
+              <a:t>mAP</a:t>
+            </a:r>
+            <a:r>
+              <a:rPr lang="es-ES" sz="2000" dirty="0"/>
+              <a:t> (</a:t>
+            </a:r>
+            <a:r>
+              <a:rPr lang="es-ES" sz="2000" dirty="0" err="1"/>
+              <a:t>overall</a:t>
+            </a:r>
+            <a:r>
+              <a:rPr lang="es-ES" sz="2000" dirty="0"/>
+              <a:t> </a:t>
+            </a:r>
+            <a:r>
+              <a:rPr lang="es-ES" sz="2000" dirty="0" err="1"/>
+              <a:t>detection</a:t>
+            </a:r>
+            <a:r>
+              <a:rPr lang="es-ES" sz="2000" dirty="0"/>
+              <a:t> performance)</a:t>
+            </a:r>
+          </a:p>
+          <a:p>
+            <a:pPr>
+              <a:buNone/>
+            </a:pPr>
+            <a:endParaRPr lang="es-ES" sz="1600" noProof="0" dirty="0">
+              <a:latin typeface="Trebuchet MS" panose="020B0603020202020204" pitchFamily="34" charset="0"/>
+            </a:endParaRPr>
+          </a:p>
+          <a:p>
+            <a:pPr algn="just"/>
+            <a:endParaRPr lang="es-ES" sz="1600" noProof="0" dirty="0">
+              <a:latin typeface="Trebuchet MS" panose="020B0603020202020204" pitchFamily="34" charset="0"/>
+            </a:endParaRPr>
+          </a:p>
+          <a:p>
+            <a:pPr marL="285750" indent="-285750" algn="just">
+              <a:buFont typeface="Arial" panose="020B0604020202020204" pitchFamily="34" charset="0"/>
+              <a:buChar char="•"/>
+            </a:pPr>
+            <a:endParaRPr lang="es-ES" sz="900" noProof="0" dirty="0">
+              <a:latin typeface="Trebuchet MS" panose="020B0603020202020204" pitchFamily="34" charset="0"/>
+            </a:endParaRPr>
+          </a:p>
+        </p:txBody>
+      </p:sp>
+      <p:sp>
+        <p:nvSpPr>
+          <p:cNvPr id="4" name="Content Placeholder 2">
+            <a:extLst>
+              <a:ext uri="{FF2B5EF4-FFF2-40B4-BE49-F238E27FC236}">
+                <a16:creationId xmlns:a16="http://schemas.microsoft.com/office/drawing/2014/main" id="{8D2CADF1-86A6-9CD6-A003-031D19C36CA4}"/>
+              </a:ext>
+            </a:extLst>
+          </p:cNvPr>
+          <p:cNvSpPr txBox="1">
+            <a:spLocks/>
+          </p:cNvSpPr>
+          <p:nvPr/>
+        </p:nvSpPr>
+        <p:spPr>
+          <a:xfrm>
+            <a:off x="4497001" y="2835841"/>
+            <a:ext cx="3920249" cy="1639178"/>
+          </a:xfrm>
+          <a:prstGeom prst="rect">
+            <a:avLst/>
+          </a:prstGeom>
+        </p:spPr>
+        <p:txBody>
+          <a:bodyPr vert="horz" lIns="91440" tIns="45720" rIns="91440" bIns="45720" rtlCol="0">
+            <a:noAutofit/>
+          </a:bodyPr>
+          <a:lstStyle>
+            <a:defPPr>
+              <a:defRPr lang="en-US"/>
+            </a:defPPr>
+            <a:lvl1pPr marL="0" algn="l" defTabSz="457200" rtl="0" eaLnBrk="1" latinLnBrk="0" hangingPunct="1">
+              <a:defRPr sz="1800" kern="1200">
+                <a:solidFill>
+                  <a:schemeClr val="tx1"/>
+                </a:solidFill>
+                <a:latin typeface="+mn-lt"/>
+                <a:ea typeface="+mn-ea"/>
+                <a:cs typeface="+mn-cs"/>
+              </a:defRPr>
+            </a:lvl1pPr>
+            <a:lvl2pPr marL="457200" algn="l" defTabSz="457200" rtl="0" eaLnBrk="1" latinLnBrk="0" hangingPunct="1">
+              <a:defRPr sz="1800" kern="1200">
+                <a:solidFill>
+                  <a:schemeClr val="tx1"/>
+                </a:solidFill>
+                <a:latin typeface="+mn-lt"/>
+                <a:ea typeface="+mn-ea"/>
+                <a:cs typeface="+mn-cs"/>
+              </a:defRPr>
+            </a:lvl2pPr>
+            <a:lvl3pPr marL="914400" algn="l" defTabSz="457200" rtl="0" eaLnBrk="1" latinLnBrk="0" hangingPunct="1">
+              <a:defRPr sz="1800" kern="1200">
+                <a:solidFill>
+                  <a:schemeClr val="tx1"/>
+                </a:solidFill>
+                <a:latin typeface="+mn-lt"/>
+                <a:ea typeface="+mn-ea"/>
+                <a:cs typeface="+mn-cs"/>
+              </a:defRPr>
+            </a:lvl3pPr>
+            <a:lvl4pPr marL="1371600" algn="l" defTabSz="457200" rtl="0" eaLnBrk="1" latinLnBrk="0" hangingPunct="1">
+              <a:defRPr sz="1800" kern="1200">
+                <a:solidFill>
+                  <a:schemeClr val="tx1"/>
+                </a:solidFill>
+                <a:latin typeface="+mn-lt"/>
+                <a:ea typeface="+mn-ea"/>
+                <a:cs typeface="+mn-cs"/>
+              </a:defRPr>
+            </a:lvl4pPr>
+            <a:lvl5pPr marL="1828800" algn="l" defTabSz="457200" rtl="0" eaLnBrk="1" latinLnBrk="0" hangingPunct="1">
+              <a:defRPr sz="1800" kern="1200">
+                <a:solidFill>
+                  <a:schemeClr val="tx1"/>
+                </a:solidFill>
+                <a:latin typeface="+mn-lt"/>
+                <a:ea typeface="+mn-ea"/>
+                <a:cs typeface="+mn-cs"/>
+              </a:defRPr>
+            </a:lvl5pPr>
+            <a:lvl6pPr marL="2286000" algn="l" defTabSz="457200" rtl="0" eaLnBrk="1" latinLnBrk="0" hangingPunct="1">
+              <a:defRPr sz="1800" kern="1200">
+                <a:solidFill>
+                  <a:schemeClr val="tx1"/>
+                </a:solidFill>
+                <a:latin typeface="+mn-lt"/>
+                <a:ea typeface="+mn-ea"/>
+                <a:cs typeface="+mn-cs"/>
+              </a:defRPr>
+            </a:lvl6pPr>
+            <a:lvl7pPr marL="2743200" algn="l" defTabSz="457200" rtl="0" eaLnBrk="1" latinLnBrk="0" hangingPunct="1">
+              <a:defRPr sz="1800" kern="1200">
+                <a:solidFill>
+                  <a:schemeClr val="tx1"/>
+                </a:solidFill>
+                <a:latin typeface="+mn-lt"/>
+                <a:ea typeface="+mn-ea"/>
+                <a:cs typeface="+mn-cs"/>
+              </a:defRPr>
+            </a:lvl7pPr>
+            <a:lvl8pPr marL="3200400" algn="l" defTabSz="457200" rtl="0" eaLnBrk="1" latinLnBrk="0" hangingPunct="1">
+              <a:defRPr sz="1800" kern="1200">
+                <a:solidFill>
+                  <a:schemeClr val="tx1"/>
+                </a:solidFill>
+                <a:latin typeface="+mn-lt"/>
+                <a:ea typeface="+mn-ea"/>
+                <a:cs typeface="+mn-cs"/>
+              </a:defRPr>
+            </a:lvl8pPr>
+            <a:lvl9pPr marL="3657600" algn="l" defTabSz="457200" rtl="0" eaLnBrk="1" latinLnBrk="0" hangingPunct="1">
+              <a:defRPr sz="1800" kern="1200">
+                <a:solidFill>
+                  <a:schemeClr val="tx1"/>
+                </a:solidFill>
+                <a:latin typeface="+mn-lt"/>
+                <a:ea typeface="+mn-ea"/>
+                <a:cs typeface="+mn-cs"/>
+              </a:defRPr>
+            </a:lvl9pPr>
+          </a:lstStyle>
+          <a:p>
+            <a:pPr>
+              <a:buNone/>
+            </a:pPr>
+            <a:r>
+              <a:rPr lang="es-ES" sz="2000" dirty="0"/>
+              <a:t>🔹 </a:t>
+            </a:r>
+            <a:r>
+              <a:rPr lang="es-ES" sz="2000" b="1" dirty="0"/>
+              <a:t>Edge </a:t>
+            </a:r>
+            <a:r>
+              <a:rPr lang="es-ES" sz="2000" b="1" dirty="0" err="1"/>
+              <a:t>Detection</a:t>
+            </a:r>
+            <a:br>
+              <a:rPr lang="es-ES" sz="2000" dirty="0"/>
+            </a:br>
+            <a:r>
+              <a:rPr lang="es-ES" sz="2000" dirty="0"/>
+              <a:t>- </a:t>
+            </a:r>
+            <a:r>
+              <a:rPr lang="es-ES" dirty="0"/>
+              <a:t>📈</a:t>
+            </a:r>
+            <a:r>
+              <a:rPr lang="es-ES" sz="2000" dirty="0"/>
+              <a:t> </a:t>
+            </a:r>
+            <a:r>
+              <a:rPr lang="es-ES" sz="2000" dirty="0" err="1"/>
+              <a:t>Precison-Recall</a:t>
+            </a:r>
+            <a:r>
+              <a:rPr lang="es-ES" sz="2000" dirty="0"/>
+              <a:t> Curve</a:t>
+            </a:r>
+          </a:p>
+          <a:p>
+            <a:pPr>
+              <a:buNone/>
+            </a:pPr>
+            <a:r>
+              <a:rPr lang="es-ES" sz="2000" noProof="0" dirty="0">
+                <a:latin typeface="Trebuchet MS" panose="020B0603020202020204" pitchFamily="34" charset="0"/>
+              </a:rPr>
+              <a:t>- </a:t>
+            </a:r>
+            <a:r>
+              <a:rPr lang="es-ES" dirty="0"/>
+              <a:t>📏</a:t>
+            </a:r>
+            <a:r>
+              <a:rPr lang="es-ES" sz="2000" dirty="0"/>
+              <a:t> </a:t>
+            </a:r>
+            <a:r>
+              <a:rPr lang="es-ES" sz="2000" noProof="0" dirty="0">
+                <a:latin typeface="Trebuchet MS" panose="020B0603020202020204" pitchFamily="34" charset="0"/>
+              </a:rPr>
+              <a:t>FOM (Edge </a:t>
+            </a:r>
+            <a:r>
+              <a:rPr lang="es-ES" sz="2000" noProof="0" dirty="0" err="1">
+                <a:latin typeface="Trebuchet MS" panose="020B0603020202020204" pitchFamily="34" charset="0"/>
+              </a:rPr>
+              <a:t>accuracy</a:t>
+            </a:r>
+            <a:r>
+              <a:rPr lang="es-ES" sz="2000" noProof="0" dirty="0">
+                <a:latin typeface="Trebuchet MS" panose="020B0603020202020204" pitchFamily="34" charset="0"/>
+              </a:rPr>
+              <a:t>)</a:t>
+            </a:r>
+            <a:endParaRPr lang="es-ES" sz="1600" noProof="0" dirty="0">
+              <a:latin typeface="Trebuchet MS" panose="020B0603020202020204" pitchFamily="34" charset="0"/>
+            </a:endParaRPr>
+          </a:p>
+          <a:p>
+            <a:pPr marL="285750" indent="-285750" algn="just">
+              <a:buFont typeface="Arial" panose="020B0604020202020204" pitchFamily="34" charset="0"/>
+              <a:buChar char="•"/>
+            </a:pPr>
+            <a:endParaRPr lang="es-ES" sz="900" noProof="0" dirty="0">
+              <a:latin typeface="Trebuchet MS" panose="020B0603020202020204" pitchFamily="34" charset="0"/>
+            </a:endParaRPr>
+          </a:p>
+        </p:txBody>
+      </p:sp>
+      <p:sp>
+        <p:nvSpPr>
+          <p:cNvPr id="5" name="Content Placeholder 2">
+            <a:extLst>
+              <a:ext uri="{FF2B5EF4-FFF2-40B4-BE49-F238E27FC236}">
+                <a16:creationId xmlns:a16="http://schemas.microsoft.com/office/drawing/2014/main" id="{18B06AEC-8D2C-DD00-AF90-35FAD079210B}"/>
+              </a:ext>
+            </a:extLst>
+          </p:cNvPr>
+          <p:cNvSpPr txBox="1">
+            <a:spLocks/>
+          </p:cNvSpPr>
+          <p:nvPr/>
+        </p:nvSpPr>
+        <p:spPr>
+          <a:xfrm>
+            <a:off x="457200" y="3802485"/>
+            <a:ext cx="3920249" cy="1639178"/>
+          </a:xfrm>
+          <a:prstGeom prst="rect">
+            <a:avLst/>
+          </a:prstGeom>
+        </p:spPr>
+        <p:txBody>
+          <a:bodyPr vert="horz" lIns="91440" tIns="45720" rIns="91440" bIns="45720" rtlCol="0">
+            <a:noAutofit/>
+          </a:bodyPr>
+          <a:lstStyle>
+            <a:defPPr>
+              <a:defRPr lang="en-US"/>
+            </a:defPPr>
+            <a:lvl1pPr marL="0" algn="l" defTabSz="457200" rtl="0" eaLnBrk="1" latinLnBrk="0" hangingPunct="1">
+              <a:defRPr sz="1800" kern="1200">
+                <a:solidFill>
+                  <a:schemeClr val="tx1"/>
+                </a:solidFill>
+                <a:latin typeface="+mn-lt"/>
+                <a:ea typeface="+mn-ea"/>
+                <a:cs typeface="+mn-cs"/>
+              </a:defRPr>
+            </a:lvl1pPr>
+            <a:lvl2pPr marL="457200" algn="l" defTabSz="457200" rtl="0" eaLnBrk="1" latinLnBrk="0" hangingPunct="1">
+              <a:defRPr sz="1800" kern="1200">
+                <a:solidFill>
+                  <a:schemeClr val="tx1"/>
+                </a:solidFill>
+                <a:latin typeface="+mn-lt"/>
+                <a:ea typeface="+mn-ea"/>
+                <a:cs typeface="+mn-cs"/>
+              </a:defRPr>
+            </a:lvl2pPr>
+            <a:lvl3pPr marL="914400" algn="l" defTabSz="457200" rtl="0" eaLnBrk="1" latinLnBrk="0" hangingPunct="1">
+              <a:defRPr sz="1800" kern="1200">
+                <a:solidFill>
+                  <a:schemeClr val="tx1"/>
+                </a:solidFill>
+                <a:latin typeface="+mn-lt"/>
+                <a:ea typeface="+mn-ea"/>
+                <a:cs typeface="+mn-cs"/>
+              </a:defRPr>
+            </a:lvl3pPr>
+            <a:lvl4pPr marL="1371600" algn="l" defTabSz="457200" rtl="0" eaLnBrk="1" latinLnBrk="0" hangingPunct="1">
+              <a:defRPr sz="1800" kern="1200">
+                <a:solidFill>
+                  <a:schemeClr val="tx1"/>
+                </a:solidFill>
+                <a:latin typeface="+mn-lt"/>
+                <a:ea typeface="+mn-ea"/>
+                <a:cs typeface="+mn-cs"/>
+              </a:defRPr>
+            </a:lvl4pPr>
+            <a:lvl5pPr marL="1828800" algn="l" defTabSz="457200" rtl="0" eaLnBrk="1" latinLnBrk="0" hangingPunct="1">
+              <a:defRPr sz="1800" kern="1200">
+                <a:solidFill>
+                  <a:schemeClr val="tx1"/>
+                </a:solidFill>
+                <a:latin typeface="+mn-lt"/>
+                <a:ea typeface="+mn-ea"/>
+                <a:cs typeface="+mn-cs"/>
+              </a:defRPr>
+            </a:lvl5pPr>
+            <a:lvl6pPr marL="2286000" algn="l" defTabSz="457200" rtl="0" eaLnBrk="1" latinLnBrk="0" hangingPunct="1">
+              <a:defRPr sz="1800" kern="1200">
+                <a:solidFill>
+                  <a:schemeClr val="tx1"/>
+                </a:solidFill>
+                <a:latin typeface="+mn-lt"/>
+                <a:ea typeface="+mn-ea"/>
+                <a:cs typeface="+mn-cs"/>
+              </a:defRPr>
+            </a:lvl6pPr>
+            <a:lvl7pPr marL="2743200" algn="l" defTabSz="457200" rtl="0" eaLnBrk="1" latinLnBrk="0" hangingPunct="1">
+              <a:defRPr sz="1800" kern="1200">
+                <a:solidFill>
+                  <a:schemeClr val="tx1"/>
+                </a:solidFill>
+                <a:latin typeface="+mn-lt"/>
+                <a:ea typeface="+mn-ea"/>
+                <a:cs typeface="+mn-cs"/>
+              </a:defRPr>
+            </a:lvl7pPr>
+            <a:lvl8pPr marL="3200400" algn="l" defTabSz="457200" rtl="0" eaLnBrk="1" latinLnBrk="0" hangingPunct="1">
+              <a:defRPr sz="1800" kern="1200">
+                <a:solidFill>
+                  <a:schemeClr val="tx1"/>
+                </a:solidFill>
+                <a:latin typeface="+mn-lt"/>
+                <a:ea typeface="+mn-ea"/>
+                <a:cs typeface="+mn-cs"/>
+              </a:defRPr>
+            </a:lvl8pPr>
+            <a:lvl9pPr marL="3657600" algn="l" defTabSz="457200" rtl="0" eaLnBrk="1" latinLnBrk="0" hangingPunct="1">
+              <a:defRPr sz="1800" kern="1200">
+                <a:solidFill>
+                  <a:schemeClr val="tx1"/>
+                </a:solidFill>
+                <a:latin typeface="+mn-lt"/>
+                <a:ea typeface="+mn-ea"/>
+                <a:cs typeface="+mn-cs"/>
+              </a:defRPr>
+            </a:lvl9pPr>
+          </a:lstStyle>
+          <a:p>
+            <a:pPr>
+              <a:buNone/>
+            </a:pPr>
+            <a:r>
+              <a:rPr lang="es-ES" sz="2000" dirty="0"/>
+              <a:t>🔹 </a:t>
+            </a:r>
+            <a:r>
+              <a:rPr lang="es-ES" sz="2000" b="1" dirty="0" err="1"/>
+              <a:t>Measurement</a:t>
+            </a:r>
+            <a:br>
+              <a:rPr lang="es-ES" sz="2000" dirty="0"/>
+            </a:br>
+            <a:r>
+              <a:rPr lang="es-ES" sz="2000" dirty="0"/>
+              <a:t>- </a:t>
+            </a:r>
+            <a:r>
+              <a:rPr lang="es-ES" dirty="0"/>
+              <a:t>📉</a:t>
+            </a:r>
+            <a:r>
+              <a:rPr lang="es-ES" sz="2000" dirty="0"/>
+              <a:t> RMSE / MAE</a:t>
+            </a:r>
+          </a:p>
+          <a:p>
+            <a:pPr>
+              <a:buNone/>
+            </a:pPr>
+            <a:r>
+              <a:rPr lang="es-ES" sz="2000" dirty="0"/>
+              <a:t>- </a:t>
+            </a:r>
+            <a:r>
+              <a:rPr lang="es-ES" dirty="0"/>
+              <a:t>📏</a:t>
+            </a:r>
+            <a:r>
+              <a:rPr lang="es-ES" sz="2000" dirty="0"/>
+              <a:t> </a:t>
+            </a:r>
+            <a:r>
+              <a:rPr lang="es-ES" sz="2000" dirty="0" err="1"/>
+              <a:t>Distance</a:t>
+            </a:r>
+            <a:r>
+              <a:rPr lang="es-ES" sz="2000" dirty="0"/>
+              <a:t> Error</a:t>
+            </a:r>
+          </a:p>
+          <a:p>
+            <a:pPr marL="285750" indent="-285750" algn="just">
+              <a:buFont typeface="Arial" panose="020B0604020202020204" pitchFamily="34" charset="0"/>
+              <a:buChar char="•"/>
+            </a:pPr>
+            <a:endParaRPr lang="es-ES" sz="900" noProof="0" dirty="0">
+              <a:latin typeface="Trebuchet MS" panose="020B0603020202020204" pitchFamily="34" charset="0"/>
+            </a:endParaRPr>
+          </a:p>
+        </p:txBody>
+      </p:sp>
     </p:spTree>
     <p:extLst>
       <p:ext uri="{BB962C8B-B14F-4D97-AF65-F5344CB8AC3E}">
@@ -4447,14 +5409,14 @@
           </a:ln>
           <a:extLst>
             <a:ext uri="{909E8E84-426E-40dd-AFC4-6F175D3DCCD1}">
-              <a14:hiddenFill xmlns:a14="http://schemas.microsoft.com/office/drawing/2010/main" xmlns="">
+              <a14:hiddenFill xmlns="" xmlns:a14="http://schemas.microsoft.com/office/drawing/2010/main">
                 <a:solidFill>
                   <a:srgbClr val="FFFFFF"/>
                 </a:solidFill>
               </a14:hiddenFill>
             </a:ext>
             <a:ext uri="{91240B29-F687-4f45-9708-019B960494DF}">
-              <a14:hiddenLine xmlns:a14="http://schemas.microsoft.com/office/drawing/2010/main" xmlns="" w="9525">
+              <a14:hiddenLine xmlns="" xmlns:a14="http://schemas.microsoft.com/office/drawing/2010/main" w="9525">
                 <a:solidFill>
                   <a:srgbClr val="000000"/>
                 </a:solidFill>
@@ -4876,14 +5838,14 @@
           </a:ln>
           <a:extLst>
             <a:ext uri="{909E8E84-426E-40dd-AFC4-6F175D3DCCD1}">
-              <a14:hiddenFill xmlns="" xmlns:a14="http://schemas.microsoft.com/office/drawing/2010/main">
+              <a14:hiddenFill xmlns:a14="http://schemas.microsoft.com/office/drawing/2010/main" xmlns="">
                 <a:solidFill>
                   <a:srgbClr val="FFFFFF"/>
                 </a:solidFill>
               </a14:hiddenFill>
             </a:ext>
             <a:ext uri="{91240B29-F687-4f45-9708-019B960494DF}">
-              <a14:hiddenLine xmlns="" xmlns:a14="http://schemas.microsoft.com/office/drawing/2010/main" w="9525">
+              <a14:hiddenLine xmlns:a14="http://schemas.microsoft.com/office/drawing/2010/main" xmlns="" w="9525">
                 <a:solidFill>
                   <a:srgbClr val="000000"/>
                 </a:solidFill>
@@ -5338,14 +6300,14 @@
           </a:ln>
           <a:extLst>
             <a:ext uri="{909E8E84-426E-40dd-AFC4-6F175D3DCCD1}">
-              <a14:hiddenFill xmlns:a14="http://schemas.microsoft.com/office/drawing/2010/main" xmlns="">
+              <a14:hiddenFill xmlns="" xmlns:a14="http://schemas.microsoft.com/office/drawing/2010/main">
                 <a:solidFill>
                   <a:srgbClr val="FFFFFF"/>
                 </a:solidFill>
               </a14:hiddenFill>
             </a:ext>
             <a:ext uri="{91240B29-F687-4f45-9708-019B960494DF}">
-              <a14:hiddenLine xmlns:a14="http://schemas.microsoft.com/office/drawing/2010/main" xmlns="" w="9525">
+              <a14:hiddenLine xmlns="" xmlns:a14="http://schemas.microsoft.com/office/drawing/2010/main" w="9525">
                 <a:solidFill>
                   <a:srgbClr val="000000"/>
                 </a:solidFill>
@@ -5583,14 +6545,14 @@
           </a:ln>
           <a:extLst>
             <a:ext uri="{909E8E84-426E-40dd-AFC4-6F175D3DCCD1}">
-              <a14:hiddenFill xmlns:a14="http://schemas.microsoft.com/office/drawing/2010/main" xmlns="">
+              <a14:hiddenFill xmlns="" xmlns:a14="http://schemas.microsoft.com/office/drawing/2010/main">
                 <a:solidFill>
                   <a:srgbClr val="FFFFFF"/>
                 </a:solidFill>
               </a14:hiddenFill>
             </a:ext>
             <a:ext uri="{91240B29-F687-4f45-9708-019B960494DF}">
-              <a14:hiddenLine xmlns:a14="http://schemas.microsoft.com/office/drawing/2010/main" xmlns="" w="9525">
+              <a14:hiddenLine xmlns="" xmlns:a14="http://schemas.microsoft.com/office/drawing/2010/main" w="9525">
                 <a:solidFill>
                   <a:srgbClr val="000000"/>
                 </a:solidFill>
@@ -5843,14 +6805,14 @@
           </a:ln>
           <a:extLst>
             <a:ext uri="{909E8E84-426E-40dd-AFC4-6F175D3DCCD1}">
-              <a14:hiddenFill xmlns="" xmlns:a14="http://schemas.microsoft.com/office/drawing/2010/main">
+              <a14:hiddenFill xmlns:a14="http://schemas.microsoft.com/office/drawing/2010/main" xmlns="">
                 <a:solidFill>
                   <a:srgbClr val="FFFFFF"/>
                 </a:solidFill>
               </a14:hiddenFill>
             </a:ext>
             <a:ext uri="{91240B29-F687-4f45-9708-019B960494DF}">
-              <a14:hiddenLine xmlns="" xmlns:a14="http://schemas.microsoft.com/office/drawing/2010/main" w="9525">
+              <a14:hiddenLine xmlns:a14="http://schemas.microsoft.com/office/drawing/2010/main" xmlns="" w="9525">
                 <a:solidFill>
                   <a:srgbClr val="000000"/>
                 </a:solidFill>
@@ -5968,14 +6930,14 @@
             </a:ln>
             <a:extLst>
               <a:ext uri="{909E8E84-426E-40dd-AFC4-6F175D3DCCD1}">
-                <a14:hiddenFill xmlns="" xmlns:a14="http://schemas.microsoft.com/office/drawing/2010/main">
+                <a14:hiddenFill xmlns:a14="http://schemas.microsoft.com/office/drawing/2010/main" xmlns="">
                   <a:solidFill>
                     <a:srgbClr val="FFFFFF"/>
                   </a:solidFill>
                 </a14:hiddenFill>
               </a:ext>
               <a:ext uri="{91240B29-F687-4f45-9708-019B960494DF}">
-                <a14:hiddenLine xmlns="" xmlns:a14="http://schemas.microsoft.com/office/drawing/2010/main" w="9525">
+                <a14:hiddenLine xmlns:a14="http://schemas.microsoft.com/office/drawing/2010/main" xmlns="" w="9525">
                   <a:solidFill>
                     <a:srgbClr val="000000"/>
                   </a:solidFill>
@@ -6094,14 +7056,14 @@
             </a:ln>
             <a:extLst>
               <a:ext uri="{909E8E84-426E-40dd-AFC4-6F175D3DCCD1}">
-                <a14:hiddenFill xmlns="" xmlns:a14="http://schemas.microsoft.com/office/drawing/2010/main">
+                <a14:hiddenFill xmlns:a14="http://schemas.microsoft.com/office/drawing/2010/main" xmlns="">
                   <a:solidFill>
                     <a:srgbClr val="FFFFFF"/>
                   </a:solidFill>
                 </a14:hiddenFill>
               </a:ext>
               <a:ext uri="{91240B29-F687-4f45-9708-019B960494DF}">
-                <a14:hiddenLine xmlns="" xmlns:a14="http://schemas.microsoft.com/office/drawing/2010/main" w="9525">
+                <a14:hiddenLine xmlns:a14="http://schemas.microsoft.com/office/drawing/2010/main" xmlns="" w="9525">
                   <a:solidFill>
                     <a:srgbClr val="000000"/>
                   </a:solidFill>
@@ -6229,14 +7191,14 @@
             </a:ln>
             <a:extLst>
               <a:ext uri="{909E8E84-426E-40dd-AFC4-6F175D3DCCD1}">
-                <a14:hiddenFill xmlns="" xmlns:a14="http://schemas.microsoft.com/office/drawing/2010/main">
+                <a14:hiddenFill xmlns:a14="http://schemas.microsoft.com/office/drawing/2010/main" xmlns="">
                   <a:solidFill>
                     <a:srgbClr val="FFFFFF"/>
                   </a:solidFill>
                 </a14:hiddenFill>
               </a:ext>
               <a:ext uri="{91240B29-F687-4f45-9708-019B960494DF}">
-                <a14:hiddenLine xmlns="" xmlns:a14="http://schemas.microsoft.com/office/drawing/2010/main" w="9525">
+                <a14:hiddenLine xmlns:a14="http://schemas.microsoft.com/office/drawing/2010/main" xmlns="" w="9525">
                   <a:solidFill>
                     <a:srgbClr val="000000"/>
                   </a:solidFill>
@@ -6359,14 +7321,14 @@
             </a:ln>
             <a:extLst>
               <a:ext uri="{909E8E84-426E-40dd-AFC4-6F175D3DCCD1}">
-                <a14:hiddenFill xmlns="" xmlns:a14="http://schemas.microsoft.com/office/drawing/2010/main">
+                <a14:hiddenFill xmlns:a14="http://schemas.microsoft.com/office/drawing/2010/main" xmlns="">
                   <a:solidFill>
                     <a:srgbClr val="FFFFFF"/>
                   </a:solidFill>
                 </a14:hiddenFill>
               </a:ext>
               <a:ext uri="{91240B29-F687-4f45-9708-019B960494DF}">
-                <a14:hiddenLine xmlns="" xmlns:a14="http://schemas.microsoft.com/office/drawing/2010/main" w="9525">
+                <a14:hiddenLine xmlns:a14="http://schemas.microsoft.com/office/drawing/2010/main" xmlns="" w="9525">
                   <a:solidFill>
                     <a:srgbClr val="000000"/>
                   </a:solidFill>
@@ -6485,14 +7447,14 @@
             </a:ln>
             <a:extLst>
               <a:ext uri="{909E8E84-426E-40dd-AFC4-6F175D3DCCD1}">
-                <a14:hiddenFill xmlns="" xmlns:a14="http://schemas.microsoft.com/office/drawing/2010/main">
+                <a14:hiddenFill xmlns:a14="http://schemas.microsoft.com/office/drawing/2010/main" xmlns="">
                   <a:solidFill>
                     <a:srgbClr val="FFFFFF"/>
                   </a:solidFill>
                 </a14:hiddenFill>
               </a:ext>
               <a:ext uri="{91240B29-F687-4f45-9708-019B960494DF}">
-                <a14:hiddenLine xmlns="" xmlns:a14="http://schemas.microsoft.com/office/drawing/2010/main" w="9525">
+                <a14:hiddenLine xmlns:a14="http://schemas.microsoft.com/office/drawing/2010/main" xmlns="" w="9525">
                   <a:solidFill>
                     <a:srgbClr val="000000"/>
                   </a:solidFill>

</xml_diff>